<commit_message>
Fix attribute_sources_with_wind, update styling, OSM User-Agent fix
</commit_message>
<xml_diff>
--- a/docs/PRAANA_Pitch_Deck.pptx
+++ b/docs/PRAANA_Pitch_Deck.pptx
@@ -177,7 +177,7 @@
             </c:spPr>
             <c:extLst>
               <c:ext xmlns:c16="http://schemas.microsoft.com/office/drawing/2014/chart" uri="{C3380CC4-5D6E-409C-BE32-E72D297353CC}">
-                <c16:uniqueId val="{00000001-0A2C-44FB-B2C4-F165CF6B64E6}"/>
+                <c16:uniqueId val="{00000001-5A4B-42E8-ABB2-97D5AE8332B2}"/>
               </c:ext>
             </c:extLst>
           </c:dPt>
@@ -192,7 +192,7 @@
             </c:spPr>
             <c:extLst>
               <c:ext xmlns:c16="http://schemas.microsoft.com/office/drawing/2014/chart" uri="{C3380CC4-5D6E-409C-BE32-E72D297353CC}">
-                <c16:uniqueId val="{00000003-0A2C-44FB-B2C4-F165CF6B64E6}"/>
+                <c16:uniqueId val="{00000003-5A4B-42E8-ABB2-97D5AE8332B2}"/>
               </c:ext>
             </c:extLst>
           </c:dPt>
@@ -207,7 +207,7 @@
             </c:spPr>
             <c:extLst>
               <c:ext xmlns:c16="http://schemas.microsoft.com/office/drawing/2014/chart" uri="{C3380CC4-5D6E-409C-BE32-E72D297353CC}">
-                <c16:uniqueId val="{00000005-0A2C-44FB-B2C4-F165CF6B64E6}"/>
+                <c16:uniqueId val="{00000005-5A4B-42E8-ABB2-97D5AE8332B2}"/>
               </c:ext>
             </c:extLst>
           </c:dPt>
@@ -243,7 +243,7 @@
                   <c15:layout/>
                 </c:ext>
                 <c:ext xmlns:c16="http://schemas.microsoft.com/office/drawing/2014/chart" uri="{C3380CC4-5D6E-409C-BE32-E72D297353CC}">
-                  <c16:uniqueId val="{00000001-0A2C-44FB-B2C4-F165CF6B64E6}"/>
+                  <c16:uniqueId val="{00000001-5A4B-42E8-ABB2-97D5AE8332B2}"/>
                 </c:ext>
               </c:extLst>
             </c:dLbl>
@@ -278,7 +278,7 @@
                   <c15:layout/>
                 </c:ext>
                 <c:ext xmlns:c16="http://schemas.microsoft.com/office/drawing/2014/chart" uri="{C3380CC4-5D6E-409C-BE32-E72D297353CC}">
-                  <c16:uniqueId val="{00000003-0A2C-44FB-B2C4-F165CF6B64E6}"/>
+                  <c16:uniqueId val="{00000003-5A4B-42E8-ABB2-97D5AE8332B2}"/>
                 </c:ext>
               </c:extLst>
             </c:dLbl>
@@ -313,7 +313,7 @@
                   <c15:layout/>
                 </c:ext>
                 <c:ext xmlns:c16="http://schemas.microsoft.com/office/drawing/2014/chart" uri="{C3380CC4-5D6E-409C-BE32-E72D297353CC}">
-                  <c16:uniqueId val="{00000005-0A2C-44FB-B2C4-F165CF6B64E6}"/>
+                  <c16:uniqueId val="{00000005-5A4B-42E8-ABB2-97D5AE8332B2}"/>
                 </c:ext>
               </c:extLst>
             </c:dLbl>
@@ -389,7 +389,7 @@
           </c:val>
           <c:extLst>
             <c:ext xmlns:c16="http://schemas.microsoft.com/office/drawing/2014/chart" uri="{C3380CC4-5D6E-409C-BE32-E72D297353CC}">
-              <c16:uniqueId val="{00000006-0A2C-44FB-B2C4-F165CF6B64E6}"/>
+              <c16:uniqueId val="{00000006-5A4B-42E8-ABB2-97D5AE8332B2}"/>
             </c:ext>
           </c:extLst>
         </c:ser>
@@ -550,7 +550,7 @@
           <c:smooth val="1"/>
           <c:extLst>
             <c:ext xmlns:c16="http://schemas.microsoft.com/office/drawing/2014/chart" uri="{C3380CC4-5D6E-409C-BE32-E72D297353CC}">
-              <c16:uniqueId val="{00000000-5B75-46FB-A2A9-1F55D344B255}"/>
+              <c16:uniqueId val="{00000000-B910-4FFF-B9A0-30DABDBB17EF}"/>
             </c:ext>
           </c:extLst>
         </c:ser>
@@ -657,7 +657,7 @@
           <c:smooth val="1"/>
           <c:extLst>
             <c:ext xmlns:c16="http://schemas.microsoft.com/office/drawing/2014/chart" uri="{C3380CC4-5D6E-409C-BE32-E72D297353CC}">
-              <c16:uniqueId val="{00000001-5B75-46FB-A2A9-1F55D344B255}"/>
+              <c16:uniqueId val="{00000001-B910-4FFF-B9A0-30DABDBB17EF}"/>
             </c:ext>
           </c:extLst>
         </c:ser>
@@ -908,7 +908,7 @@
           </c:val>
           <c:extLst>
             <c:ext xmlns:c16="http://schemas.microsoft.com/office/drawing/2014/chart" uri="{C3380CC4-5D6E-409C-BE32-E72D297353CC}">
-              <c16:uniqueId val="{00000000-77ED-4D36-B824-7B21AD48AD75}"/>
+              <c16:uniqueId val="{00000000-11B2-4382-B6C2-1B902CBF46C7}"/>
             </c:ext>
           </c:extLst>
         </c:ser>
@@ -1093,7 +1093,7 @@
             </c:spPr>
             <c:extLst>
               <c:ext xmlns:c16="http://schemas.microsoft.com/office/drawing/2014/chart" uri="{C3380CC4-5D6E-409C-BE32-E72D297353CC}">
-                <c16:uniqueId val="{00000001-51E2-4D9A-9969-B9FBAF482060}"/>
+                <c16:uniqueId val="{00000001-59CB-4A6C-A158-7CF0804522FB}"/>
               </c:ext>
             </c:extLst>
           </c:dPt>
@@ -1108,7 +1108,7 @@
             </c:spPr>
             <c:extLst>
               <c:ext xmlns:c16="http://schemas.microsoft.com/office/drawing/2014/chart" uri="{C3380CC4-5D6E-409C-BE32-E72D297353CC}">
-                <c16:uniqueId val="{00000003-51E2-4D9A-9969-B9FBAF482060}"/>
+                <c16:uniqueId val="{00000003-59CB-4A6C-A158-7CF0804522FB}"/>
               </c:ext>
             </c:extLst>
           </c:dPt>
@@ -1123,7 +1123,7 @@
             </c:spPr>
             <c:extLst>
               <c:ext xmlns:c16="http://schemas.microsoft.com/office/drawing/2014/chart" uri="{C3380CC4-5D6E-409C-BE32-E72D297353CC}">
-                <c16:uniqueId val="{00000005-51E2-4D9A-9969-B9FBAF482060}"/>
+                <c16:uniqueId val="{00000005-59CB-4A6C-A158-7CF0804522FB}"/>
               </c:ext>
             </c:extLst>
           </c:dPt>
@@ -1138,7 +1138,7 @@
             </c:spPr>
             <c:extLst>
               <c:ext xmlns:c16="http://schemas.microsoft.com/office/drawing/2014/chart" uri="{C3380CC4-5D6E-409C-BE32-E72D297353CC}">
-                <c16:uniqueId val="{00000007-51E2-4D9A-9969-B9FBAF482060}"/>
+                <c16:uniqueId val="{00000007-59CB-4A6C-A158-7CF0804522FB}"/>
               </c:ext>
             </c:extLst>
           </c:dPt>
@@ -1153,7 +1153,7 @@
             </c:spPr>
             <c:extLst>
               <c:ext xmlns:c16="http://schemas.microsoft.com/office/drawing/2014/chart" uri="{C3380CC4-5D6E-409C-BE32-E72D297353CC}">
-                <c16:uniqueId val="{00000009-51E2-4D9A-9969-B9FBAF482060}"/>
+                <c16:uniqueId val="{00000009-59CB-4A6C-A158-7CF0804522FB}"/>
               </c:ext>
             </c:extLst>
           </c:dPt>
@@ -1189,7 +1189,7 @@
                   <c15:layout/>
                 </c:ext>
                 <c:ext xmlns:c16="http://schemas.microsoft.com/office/drawing/2014/chart" uri="{C3380CC4-5D6E-409C-BE32-E72D297353CC}">
-                  <c16:uniqueId val="{00000001-51E2-4D9A-9969-B9FBAF482060}"/>
+                  <c16:uniqueId val="{00000001-59CB-4A6C-A158-7CF0804522FB}"/>
                 </c:ext>
               </c:extLst>
             </c:dLbl>
@@ -1224,7 +1224,7 @@
                   <c15:layout/>
                 </c:ext>
                 <c:ext xmlns:c16="http://schemas.microsoft.com/office/drawing/2014/chart" uri="{C3380CC4-5D6E-409C-BE32-E72D297353CC}">
-                  <c16:uniqueId val="{00000003-51E2-4D9A-9969-B9FBAF482060}"/>
+                  <c16:uniqueId val="{00000003-59CB-4A6C-A158-7CF0804522FB}"/>
                 </c:ext>
               </c:extLst>
             </c:dLbl>
@@ -1259,7 +1259,7 @@
                   <c15:layout/>
                 </c:ext>
                 <c:ext xmlns:c16="http://schemas.microsoft.com/office/drawing/2014/chart" uri="{C3380CC4-5D6E-409C-BE32-E72D297353CC}">
-                  <c16:uniqueId val="{00000005-51E2-4D9A-9969-B9FBAF482060}"/>
+                  <c16:uniqueId val="{00000005-59CB-4A6C-A158-7CF0804522FB}"/>
                 </c:ext>
               </c:extLst>
             </c:dLbl>
@@ -1294,7 +1294,7 @@
                   <c15:layout/>
                 </c:ext>
                 <c:ext xmlns:c16="http://schemas.microsoft.com/office/drawing/2014/chart" uri="{C3380CC4-5D6E-409C-BE32-E72D297353CC}">
-                  <c16:uniqueId val="{00000007-51E2-4D9A-9969-B9FBAF482060}"/>
+                  <c16:uniqueId val="{00000007-59CB-4A6C-A158-7CF0804522FB}"/>
                 </c:ext>
               </c:extLst>
             </c:dLbl>
@@ -1329,7 +1329,7 @@
                   <c15:layout/>
                 </c:ext>
                 <c:ext xmlns:c16="http://schemas.microsoft.com/office/drawing/2014/chart" uri="{C3380CC4-5D6E-409C-BE32-E72D297353CC}">
-                  <c16:uniqueId val="{00000009-51E2-4D9A-9969-B9FBAF482060}"/>
+                  <c16:uniqueId val="{00000009-59CB-4A6C-A158-7CF0804522FB}"/>
                 </c:ext>
               </c:extLst>
             </c:dLbl>
@@ -1416,7 +1416,7 @@
           </c:val>
           <c:extLst>
             <c:ext xmlns:c16="http://schemas.microsoft.com/office/drawing/2014/chart" uri="{C3380CC4-5D6E-409C-BE32-E72D297353CC}">
-              <c16:uniqueId val="{0000000A-51E2-4D9A-9969-B9FBAF482060}"/>
+              <c16:uniqueId val="{0000000A-59CB-4A6C-A158-7CF0804522FB}"/>
             </c:ext>
           </c:extLst>
         </c:ser>
@@ -1487,7 +1487,7 @@
     </p:spTree>
     <p:extLst>
       <p:ext uri="{BB962C8B-B14F-4D97-AF65-F5344CB8AC3E}">
-        <p14:creationId xmlns:p14="http://schemas.microsoft.com/office/powerpoint/2010/main" val="1825998241"/>
+        <p14:creationId xmlns:p14="http://schemas.microsoft.com/office/powerpoint/2010/main" val="923210878"/>
       </p:ext>
     </p:extLst>
   </p:cSld>
@@ -3466,7 +3466,57 @@
       </p:sp>
       <p:sp>
         <p:nvSpPr>
-          <p:cNvPr id="8" name="Shape 6"/>
+          <p:cNvPr id="8" name="Text 6"/>
+          <p:cNvSpPr/>
+          <p:nvPr/>
+        </p:nvSpPr>
+        <p:spPr>
+          <a:xfrm>
+            <a:off x="594360" y="4114800"/>
+            <a:ext cx="3657600" cy="320040"/>
+          </a:xfrm>
+          <a:prstGeom prst="rect">
+            <a:avLst/>
+          </a:prstGeom>
+          <a:noFill/>
+          <a:ln/>
+        </p:spPr>
+        <p:txBody>
+          <a:bodyPr wrap="square" lIns="0" tIns="0" rIns="0" bIns="0" rtlCol="0" anchor="ctr"/>
+          <a:lstStyle/>
+          <a:p>
+            <a:pPr marL="0" indent="0">
+              <a:buNone/>
+            </a:pPr>
+            <a:r>
+              <a:rPr lang="en-US" sz="1300" dirty="0">
+                <a:solidFill>
+                  <a:srgbClr val="DCEAF2"/>
+                </a:solidFill>
+                <a:latin typeface="Calibri" pitchFamily="34" charset="0"/>
+                <a:ea typeface="Calibri" pitchFamily="34" charset="-122"/>
+                <a:cs typeface="Calibri" pitchFamily="34" charset="-120"/>
+              </a:rPr>
+              <a:t>Team </a:t>
+            </a:r>
+            <a:r>
+              <a:rPr lang="en-US" sz="1300" dirty="0" err="1" smtClean="0">
+                <a:solidFill>
+                  <a:srgbClr val="DCEAF2"/>
+                </a:solidFill>
+                <a:latin typeface="Calibri" pitchFamily="34" charset="0"/>
+                <a:ea typeface="Calibri" pitchFamily="34" charset="-122"/>
+                <a:cs typeface="Calibri" pitchFamily="34" charset="-120"/>
+              </a:rPr>
+              <a:t>Pheonix</a:t>
+            </a:r>
+            <a:endParaRPr lang="en-US" sz="1300" dirty="0"/>
+          </a:p>
+        </p:txBody>
+      </p:sp>
+      <p:sp>
+        <p:nvSpPr>
+          <p:cNvPr id="9" name="Shape 7"/>
           <p:cNvSpPr/>
           <p:nvPr/>
         </p:nvSpPr>
@@ -3486,7 +3536,7 @@
       </p:sp>
       <p:pic>
         <p:nvPicPr>
-          <p:cNvPr id="9" name="Image 0" descr="preencoded.png"/>
+          <p:cNvPr id="10" name="Image 0" descr="preencoded.png"/>
           <p:cNvPicPr>
             <a:picLocks noChangeAspect="1"/>
           </p:cNvPicPr>
@@ -3510,7 +3560,7 @@
       </p:pic>
       <p:sp>
         <p:nvSpPr>
-          <p:cNvPr id="10" name="Text 7"/>
+          <p:cNvPr id="11" name="Text 8"/>
           <p:cNvSpPr/>
           <p:nvPr/>
         </p:nvSpPr>
@@ -3549,7 +3599,7 @@
       </p:sp>
       <p:sp>
         <p:nvSpPr>
-          <p:cNvPr id="11" name="Shape 8"/>
+          <p:cNvPr id="12" name="Shape 9"/>
           <p:cNvSpPr/>
           <p:nvPr/>
         </p:nvSpPr>
@@ -3572,7 +3622,7 @@
       </p:sp>
       <p:sp>
         <p:nvSpPr>
-          <p:cNvPr id="12" name="Shape 9"/>
+          <p:cNvPr id="13" name="Shape 10"/>
           <p:cNvSpPr/>
           <p:nvPr/>
         </p:nvSpPr>
@@ -3592,7 +3642,7 @@
       </p:sp>
       <p:pic>
         <p:nvPicPr>
-          <p:cNvPr id="13" name="Image 1" descr="preencoded.png"/>
+          <p:cNvPr id="14" name="Image 1" descr="preencoded.png"/>
           <p:cNvPicPr>
             <a:picLocks noChangeAspect="1"/>
           </p:cNvPicPr>
@@ -3616,7 +3666,7 @@
       </p:pic>
       <p:sp>
         <p:nvSpPr>
-          <p:cNvPr id="14" name="Text 10"/>
+          <p:cNvPr id="15" name="Text 11"/>
           <p:cNvSpPr/>
           <p:nvPr/>
         </p:nvSpPr>
@@ -3655,7 +3705,7 @@
       </p:sp>
       <p:sp>
         <p:nvSpPr>
-          <p:cNvPr id="15" name="Shape 11"/>
+          <p:cNvPr id="16" name="Shape 12"/>
           <p:cNvSpPr/>
           <p:nvPr/>
         </p:nvSpPr>
@@ -3678,7 +3728,7 @@
       </p:sp>
       <p:sp>
         <p:nvSpPr>
-          <p:cNvPr id="16" name="Shape 12"/>
+          <p:cNvPr id="17" name="Shape 13"/>
           <p:cNvSpPr/>
           <p:nvPr/>
         </p:nvSpPr>
@@ -3698,7 +3748,7 @@
       </p:sp>
       <p:pic>
         <p:nvPicPr>
-          <p:cNvPr id="17" name="Image 2" descr="preencoded.png"/>
+          <p:cNvPr id="18" name="Image 2" descr="preencoded.png"/>
           <p:cNvPicPr>
             <a:picLocks noChangeAspect="1"/>
           </p:cNvPicPr>
@@ -3722,7 +3772,7 @@
       </p:pic>
       <p:sp>
         <p:nvSpPr>
-          <p:cNvPr id="18" name="Text 13"/>
+          <p:cNvPr id="19" name="Text 14"/>
           <p:cNvSpPr/>
           <p:nvPr/>
         </p:nvSpPr>
@@ -3761,7 +3811,7 @@
       </p:sp>
       <p:sp>
         <p:nvSpPr>
-          <p:cNvPr id="19" name="Shape 14"/>
+          <p:cNvPr id="20" name="Shape 15"/>
           <p:cNvSpPr/>
           <p:nvPr/>
         </p:nvSpPr>
@@ -3784,7 +3834,7 @@
       </p:sp>
       <p:sp>
         <p:nvSpPr>
-          <p:cNvPr id="20" name="Shape 15"/>
+          <p:cNvPr id="21" name="Shape 16"/>
           <p:cNvSpPr/>
           <p:nvPr/>
         </p:nvSpPr>
@@ -3804,7 +3854,7 @@
       </p:sp>
       <p:pic>
         <p:nvPicPr>
-          <p:cNvPr id="21" name="Image 3" descr="preencoded.png"/>
+          <p:cNvPr id="22" name="Image 3" descr="preencoded.png"/>
           <p:cNvPicPr>
             <a:picLocks noChangeAspect="1"/>
           </p:cNvPicPr>
@@ -3828,7 +3878,7 @@
       </p:pic>
       <p:sp>
         <p:nvSpPr>
-          <p:cNvPr id="22" name="Text 16"/>
+          <p:cNvPr id="23" name="Text 17"/>
           <p:cNvSpPr/>
           <p:nvPr/>
         </p:nvSpPr>
@@ -3862,6 +3912,45 @@
               <a:t>Communicate</a:t>
             </a:r>
             <a:endParaRPr lang="en-US" sz="1050" dirty="0"/>
+          </a:p>
+        </p:txBody>
+      </p:sp>
+      <p:sp>
+        <p:nvSpPr>
+          <p:cNvPr id="24" name="Text 18"/>
+          <p:cNvSpPr/>
+          <p:nvPr/>
+        </p:nvSpPr>
+        <p:spPr>
+          <a:xfrm>
+            <a:off x="594360" y="6035040"/>
+            <a:ext cx="5486400" cy="320040"/>
+          </a:xfrm>
+          <a:prstGeom prst="rect">
+            <a:avLst/>
+          </a:prstGeom>
+          <a:noFill/>
+          <a:ln/>
+        </p:spPr>
+        <p:txBody>
+          <a:bodyPr wrap="square" lIns="0" tIns="0" rIns="0" bIns="0" rtlCol="0" anchor="ctr"/>
+          <a:lstStyle/>
+          <a:p>
+            <a:pPr marL="0" indent="0">
+              <a:buNone/>
+            </a:pPr>
+            <a:r>
+              <a:rPr lang="en-US" sz="1100" dirty="0">
+                <a:solidFill>
+                  <a:srgbClr val="5C6B73"/>
+                </a:solidFill>
+                <a:latin typeface="Calibri" pitchFamily="34" charset="0"/>
+                <a:ea typeface="Calibri" pitchFamily="34" charset="-122"/>
+                <a:cs typeface="Calibri" pitchFamily="34" charset="-120"/>
+              </a:rPr>
+              <a:t>Detailed Solution Document &amp; Pitch Deck</a:t>
+            </a:r>
+            <a:endParaRPr lang="en-US" sz="1100" dirty="0"/>
           </a:p>
         </p:txBody>
       </p:sp>
@@ -4877,6 +4966,84 @@
           </a:p>
         </p:txBody>
       </p:sp>
+      <p:sp>
+        <p:nvSpPr>
+          <p:cNvPr id="33" name="Text 26"/>
+          <p:cNvSpPr/>
+          <p:nvPr/>
+        </p:nvSpPr>
+        <p:spPr>
+          <a:xfrm>
+            <a:off x="11002975" y="6419088"/>
+            <a:ext cx="822960" cy="274320"/>
+          </a:xfrm>
+          <a:prstGeom prst="rect">
+            <a:avLst/>
+          </a:prstGeom>
+          <a:noFill/>
+          <a:ln/>
+        </p:spPr>
+        <p:txBody>
+          <a:bodyPr wrap="square" lIns="0" tIns="0" rIns="0" bIns="0" rtlCol="0" anchor="ctr"/>
+          <a:lstStyle/>
+          <a:p>
+            <a:pPr marL="0" indent="0" algn="r">
+              <a:buNone/>
+            </a:pPr>
+            <a:r>
+              <a:rPr lang="en-US" sz="900" dirty="0">
+                <a:solidFill>
+                  <a:srgbClr val="5C6B73"/>
+                </a:solidFill>
+                <a:latin typeface="Calibri" pitchFamily="34" charset="0"/>
+                <a:ea typeface="Calibri" pitchFamily="34" charset="-122"/>
+                <a:cs typeface="Calibri" pitchFamily="34" charset="-120"/>
+              </a:rPr>
+              <a:t>10 / 16</a:t>
+            </a:r>
+            <a:endParaRPr lang="en-US" sz="900" dirty="0"/>
+          </a:p>
+        </p:txBody>
+      </p:sp>
+      <p:sp>
+        <p:nvSpPr>
+          <p:cNvPr id="34" name="Text 27"/>
+          <p:cNvSpPr/>
+          <p:nvPr/>
+        </p:nvSpPr>
+        <p:spPr>
+          <a:xfrm>
+            <a:off x="594360" y="6419088"/>
+            <a:ext cx="4572000" cy="274320"/>
+          </a:xfrm>
+          <a:prstGeom prst="rect">
+            <a:avLst/>
+          </a:prstGeom>
+          <a:noFill/>
+          <a:ln/>
+        </p:spPr>
+        <p:txBody>
+          <a:bodyPr wrap="square" lIns="0" tIns="0" rIns="0" bIns="0" rtlCol="0" anchor="ctr"/>
+          <a:lstStyle/>
+          <a:p>
+            <a:pPr marL="0" indent="0">
+              <a:buNone/>
+            </a:pPr>
+            <a:r>
+              <a:rPr lang="en-US" sz="900" dirty="0">
+                <a:solidFill>
+                  <a:srgbClr val="5C6B73"/>
+                </a:solidFill>
+                <a:latin typeface="Calibri" pitchFamily="34" charset="0"/>
+                <a:ea typeface="Calibri" pitchFamily="34" charset="-122"/>
+                <a:cs typeface="Calibri" pitchFamily="34" charset="-120"/>
+              </a:rPr>
+              <a:t>PRAANA — ET AI Hackathon 2026</a:t>
+            </a:r>
+            <a:endParaRPr lang="en-US" sz="900" dirty="0"/>
+          </a:p>
+        </p:txBody>
+      </p:sp>
     </p:spTree>
   </p:cSld>
   <p:clrMapOvr>
@@ -5231,7 +5398,7 @@
                 <a:ea typeface="Calibri" pitchFamily="34" charset="-122"/>
                 <a:cs typeface="Calibri" pitchFamily="34" charset="-120"/>
               </a:rPr>
-              <a:t>Answers natural questions: ‘Is it safe to walk my child to school tomorrow?’</a:t>
+              <a:t>Answers natural questions: 'Is it safe to walk my child to school tomorrow?'</a:t>
             </a:r>
             <a:endParaRPr lang="en-US" sz="1250" dirty="0"/>
           </a:p>
@@ -5464,26 +5631,6 @@
         </p:nvSpPr>
         <p:spPr>
           <a:xfrm>
-            <a:off x="6949440" y="2459736"/>
-            <a:ext cx="274320" cy="274320"/>
-          </a:xfrm>
-          <a:prstGeom prst="ellipse">
-            <a:avLst/>
-          </a:prstGeom>
-          <a:solidFill>
-            <a:srgbClr val="DCEAF2"/>
-          </a:solidFill>
-          <a:ln/>
-        </p:spPr>
-      </p:sp>
-      <p:sp>
-        <p:nvSpPr>
-          <p:cNvPr id="21" name="Shape 15"/>
-          <p:cNvSpPr/>
-          <p:nvPr/>
-        </p:nvSpPr>
-        <p:spPr>
-          <a:xfrm>
             <a:off x="6949440" y="2423160"/>
             <a:ext cx="310896" cy="310896"/>
           </a:xfrm>
@@ -5498,7 +5645,7 @@
       </p:sp>
       <p:pic>
         <p:nvPicPr>
-          <p:cNvPr id="22" name="Image 4" descr="preencoded.png"/>
+          <p:cNvPr id="21" name="Image 4" descr="preencoded.png"/>
           <p:cNvPicPr>
             <a:picLocks noChangeAspect="1"/>
           </p:cNvPicPr>
@@ -5522,7 +5669,7 @@
       </p:pic>
       <p:sp>
         <p:nvSpPr>
-          <p:cNvPr id="23" name="Text 16"/>
+          <p:cNvPr id="22" name="Text 15"/>
           <p:cNvSpPr/>
           <p:nvPr/>
         </p:nvSpPr>
@@ -5572,27 +5719,7 @@
       </p:sp>
       <p:sp>
         <p:nvSpPr>
-          <p:cNvPr id="24" name="Shape 17"/>
-          <p:cNvSpPr/>
-          <p:nvPr/>
-        </p:nvSpPr>
-        <p:spPr>
-          <a:xfrm>
-            <a:off x="6949440" y="3026664"/>
-            <a:ext cx="274320" cy="274320"/>
-          </a:xfrm>
-          <a:prstGeom prst="ellipse">
-            <a:avLst/>
-          </a:prstGeom>
-          <a:solidFill>
-            <a:srgbClr val="DCEAF2"/>
-          </a:solidFill>
-          <a:ln/>
-        </p:spPr>
-      </p:sp>
-      <p:sp>
-        <p:nvSpPr>
-          <p:cNvPr id="25" name="Shape 18"/>
+          <p:cNvPr id="23" name="Shape 16"/>
           <p:cNvSpPr/>
           <p:nvPr/>
         </p:nvSpPr>
@@ -5612,7 +5739,7 @@
       </p:sp>
       <p:pic>
         <p:nvPicPr>
-          <p:cNvPr id="26" name="Image 5" descr="preencoded.png"/>
+          <p:cNvPr id="24" name="Image 5" descr="preencoded.png"/>
           <p:cNvPicPr>
             <a:picLocks noChangeAspect="1"/>
           </p:cNvPicPr>
@@ -5636,7 +5763,7 @@
       </p:pic>
       <p:sp>
         <p:nvSpPr>
-          <p:cNvPr id="27" name="Text 19"/>
+          <p:cNvPr id="25" name="Text 17"/>
           <p:cNvSpPr/>
           <p:nvPr/>
         </p:nvSpPr>
@@ -5686,27 +5813,7 @@
       </p:sp>
       <p:sp>
         <p:nvSpPr>
-          <p:cNvPr id="28" name="Shape 20"/>
-          <p:cNvSpPr/>
-          <p:nvPr/>
-        </p:nvSpPr>
-        <p:spPr>
-          <a:xfrm>
-            <a:off x="6949440" y="3593592"/>
-            <a:ext cx="274320" cy="274320"/>
-          </a:xfrm>
-          <a:prstGeom prst="ellipse">
-            <a:avLst/>
-          </a:prstGeom>
-          <a:solidFill>
-            <a:srgbClr val="DCEAF2"/>
-          </a:solidFill>
-          <a:ln/>
-        </p:spPr>
-      </p:sp>
-      <p:sp>
-        <p:nvSpPr>
-          <p:cNvPr id="29" name="Shape 21"/>
+          <p:cNvPr id="26" name="Shape 18"/>
           <p:cNvSpPr/>
           <p:nvPr/>
         </p:nvSpPr>
@@ -5726,7 +5833,7 @@
       </p:sp>
       <p:pic>
         <p:nvPicPr>
-          <p:cNvPr id="30" name="Image 6" descr="preencoded.png"/>
+          <p:cNvPr id="27" name="Image 6" descr="preencoded.png"/>
           <p:cNvPicPr>
             <a:picLocks noChangeAspect="1"/>
           </p:cNvPicPr>
@@ -5750,7 +5857,7 @@
       </p:pic>
       <p:sp>
         <p:nvSpPr>
-          <p:cNvPr id="31" name="Text 22"/>
+          <p:cNvPr id="28" name="Text 19"/>
           <p:cNvSpPr/>
           <p:nvPr/>
         </p:nvSpPr>
@@ -5800,27 +5907,7 @@
       </p:sp>
       <p:sp>
         <p:nvSpPr>
-          <p:cNvPr id="32" name="Shape 23"/>
-          <p:cNvSpPr/>
-          <p:nvPr/>
-        </p:nvSpPr>
-        <p:spPr>
-          <a:xfrm>
-            <a:off x="6949440" y="4160520"/>
-            <a:ext cx="274320" cy="274320"/>
-          </a:xfrm>
-          <a:prstGeom prst="ellipse">
-            <a:avLst/>
-          </a:prstGeom>
-          <a:solidFill>
-            <a:srgbClr val="DCEAF2"/>
-          </a:solidFill>
-          <a:ln/>
-        </p:spPr>
-      </p:sp>
-      <p:sp>
-        <p:nvSpPr>
-          <p:cNvPr id="33" name="Shape 24"/>
+          <p:cNvPr id="29" name="Shape 20"/>
           <p:cNvSpPr/>
           <p:nvPr/>
         </p:nvSpPr>
@@ -5840,7 +5927,7 @@
       </p:sp>
       <p:pic>
         <p:nvPicPr>
-          <p:cNvPr id="34" name="Image 7" descr="preencoded.png"/>
+          <p:cNvPr id="30" name="Image 7" descr="preencoded.png"/>
           <p:cNvPicPr>
             <a:picLocks noChangeAspect="1"/>
           </p:cNvPicPr>
@@ -5864,7 +5951,7 @@
       </p:pic>
       <p:sp>
         <p:nvSpPr>
-          <p:cNvPr id="35" name="Text 25"/>
+          <p:cNvPr id="31" name="Text 21"/>
           <p:cNvSpPr/>
           <p:nvPr/>
         </p:nvSpPr>
@@ -5914,27 +6001,7 @@
       </p:sp>
       <p:sp>
         <p:nvSpPr>
-          <p:cNvPr id="36" name="Shape 26"/>
-          <p:cNvSpPr/>
-          <p:nvPr/>
-        </p:nvSpPr>
-        <p:spPr>
-          <a:xfrm>
-            <a:off x="6949440" y="4727448"/>
-            <a:ext cx="274320" cy="274320"/>
-          </a:xfrm>
-          <a:prstGeom prst="ellipse">
-            <a:avLst/>
-          </a:prstGeom>
-          <a:solidFill>
-            <a:srgbClr val="DCEAF2"/>
-          </a:solidFill>
-          <a:ln/>
-        </p:spPr>
-      </p:sp>
-      <p:sp>
-        <p:nvSpPr>
-          <p:cNvPr id="37" name="Shape 27"/>
+          <p:cNvPr id="32" name="Shape 22"/>
           <p:cNvSpPr/>
           <p:nvPr/>
         </p:nvSpPr>
@@ -5954,7 +6021,7 @@
       </p:sp>
       <p:pic>
         <p:nvPicPr>
-          <p:cNvPr id="38" name="Image 8" descr="preencoded.png"/>
+          <p:cNvPr id="33" name="Image 8" descr="preencoded.png"/>
           <p:cNvPicPr>
             <a:picLocks noChangeAspect="1"/>
           </p:cNvPicPr>
@@ -5978,7 +6045,7 @@
       </p:pic>
       <p:sp>
         <p:nvSpPr>
-          <p:cNvPr id="39" name="Text 28"/>
+          <p:cNvPr id="34" name="Text 23"/>
           <p:cNvSpPr/>
           <p:nvPr/>
         </p:nvSpPr>
@@ -6028,30 +6095,30 @@
       </p:sp>
       <p:sp>
         <p:nvSpPr>
-          <p:cNvPr id="40" name="Text 29"/>
-          <p:cNvSpPr/>
-          <p:nvPr/>
-        </p:nvSpPr>
-        <p:spPr>
-          <a:xfrm>
-            <a:off x="6949440" y="5349240"/>
-            <a:ext cx="4419295" cy="640080"/>
-          </a:xfrm>
-          <a:prstGeom prst="rect">
-            <a:avLst/>
-          </a:prstGeom>
-          <a:noFill/>
-          <a:ln/>
-        </p:spPr>
-        <p:txBody>
-          <a:bodyPr wrap="square" lIns="0" tIns="0" rIns="0" bIns="0" rtlCol="0" anchor="ctr"/>
-          <a:lstStyle/>
-          <a:p>
-            <a:pPr marL="0" indent="0">
-              <a:buNone/>
-            </a:pPr>
-            <a:r>
-              <a:rPr lang="en-US" sz="1000" i="1" dirty="0">
+          <p:cNvPr id="35" name="Text 24"/>
+          <p:cNvSpPr/>
+          <p:nvPr/>
+        </p:nvSpPr>
+        <p:spPr>
+          <a:xfrm>
+            <a:off x="11002975" y="6419088"/>
+            <a:ext cx="822960" cy="274320"/>
+          </a:xfrm>
+          <a:prstGeom prst="rect">
+            <a:avLst/>
+          </a:prstGeom>
+          <a:noFill/>
+          <a:ln/>
+        </p:spPr>
+        <p:txBody>
+          <a:bodyPr wrap="square" lIns="0" tIns="0" rIns="0" bIns="0" rtlCol="0" anchor="ctr"/>
+          <a:lstStyle/>
+          <a:p>
+            <a:pPr marL="0" indent="0" algn="r">
+              <a:buNone/>
+            </a:pPr>
+            <a:r>
+              <a:rPr lang="en-US" sz="900" dirty="0">
                 <a:solidFill>
                   <a:srgbClr val="5C6B73"/>
                 </a:solidFill>
@@ -6059,9 +6126,48 @@
                 <a:ea typeface="Calibri" pitchFamily="34" charset="-122"/>
                 <a:cs typeface="Calibri" pitchFamily="34" charset="-120"/>
               </a:rPr>
-              <a:t>+ IVR for low-smartphone-penetration areas, and public-display screens near schools and hospitals.</a:t>
-            </a:r>
-            <a:endParaRPr lang="en-US" sz="1000" dirty="0"/>
+              <a:t>11 / 16</a:t>
+            </a:r>
+            <a:endParaRPr lang="en-US" sz="900" dirty="0"/>
+          </a:p>
+        </p:txBody>
+      </p:sp>
+      <p:sp>
+        <p:nvSpPr>
+          <p:cNvPr id="36" name="Text 25"/>
+          <p:cNvSpPr/>
+          <p:nvPr/>
+        </p:nvSpPr>
+        <p:spPr>
+          <a:xfrm>
+            <a:off x="594360" y="6419088"/>
+            <a:ext cx="4572000" cy="274320"/>
+          </a:xfrm>
+          <a:prstGeom prst="rect">
+            <a:avLst/>
+          </a:prstGeom>
+          <a:noFill/>
+          <a:ln/>
+        </p:spPr>
+        <p:txBody>
+          <a:bodyPr wrap="square" lIns="0" tIns="0" rIns="0" bIns="0" rtlCol="0" anchor="ctr"/>
+          <a:lstStyle/>
+          <a:p>
+            <a:pPr marL="0" indent="0">
+              <a:buNone/>
+            </a:pPr>
+            <a:r>
+              <a:rPr lang="en-US" sz="900" dirty="0">
+                <a:solidFill>
+                  <a:srgbClr val="5C6B73"/>
+                </a:solidFill>
+                <a:latin typeface="Calibri" pitchFamily="34" charset="0"/>
+                <a:ea typeface="Calibri" pitchFamily="34" charset="-122"/>
+                <a:cs typeface="Calibri" pitchFamily="34" charset="-120"/>
+              </a:rPr>
+              <a:t>PRAANA — ET AI Hackathon 2026</a:t>
+            </a:r>
+            <a:endParaRPr lang="en-US" sz="900" dirty="0"/>
           </a:p>
         </p:txBody>
       </p:sp>
@@ -6257,8 +6363,8 @@
         </p:nvSpPr>
         <p:spPr>
           <a:xfrm>
-            <a:off x="704088" y="2560320"/>
-            <a:ext cx="2377440" cy="502920"/>
+            <a:off x="704088" y="2551176"/>
+            <a:ext cx="2377440" cy="438912"/>
           </a:xfrm>
           <a:prstGeom prst="rect">
             <a:avLst/>
@@ -6274,7 +6380,7 @@
               <a:buNone/>
             </a:pPr>
             <a:r>
-              <a:rPr lang="en-US" sz="1150" b="1" dirty="0">
+              <a:rPr lang="en-US" sz="1100" b="1" dirty="0">
                 <a:solidFill>
                   <a:srgbClr val="1B3B5F"/>
                 </a:solidFill>
@@ -6284,7 +6390,7 @@
               </a:rPr>
               <a:t>Geospatial &amp; Remote Sensing</a:t>
             </a:r>
-            <a:endParaRPr lang="en-US" sz="1150" dirty="0"/>
+            <a:endParaRPr lang="en-US" sz="1100" dirty="0"/>
           </a:p>
         </p:txBody>
       </p:sp>
@@ -6296,8 +6402,8 @@
         </p:nvSpPr>
         <p:spPr>
           <a:xfrm>
-            <a:off x="704088" y="3044952"/>
-            <a:ext cx="2377440" cy="530352"/>
+            <a:off x="704088" y="2971800"/>
+            <a:ext cx="2377440" cy="621792"/>
           </a:xfrm>
           <a:prstGeom prst="rect">
             <a:avLst/>
@@ -6313,7 +6419,7 @@
               <a:buNone/>
             </a:pPr>
             <a:r>
-              <a:rPr lang="en-US" sz="900" dirty="0">
+              <a:rPr lang="en-US" sz="850" dirty="0">
                 <a:solidFill>
                   <a:srgbClr val="5C6B73"/>
                 </a:solidFill>
@@ -6321,9 +6427,9 @@
                 <a:ea typeface="Calibri" pitchFamily="34" charset="-122"/>
                 <a:cs typeface="Calibri" pitchFamily="34" charset="-120"/>
               </a:rPr>
-              <a:t>Sentinel-5P + MODIS + OpenStreetMap</a:t>
-            </a:r>
-            <a:endParaRPr lang="en-US" sz="900" dirty="0"/>
+              <a:t>Sentinel-5P + MODIS + OSM Overpass API</a:t>
+            </a:r>
+            <a:endParaRPr lang="en-US" sz="850" dirty="0"/>
           </a:p>
         </p:txBody>
       </p:sp>
@@ -6408,8 +6514,8 @@
         </p:nvSpPr>
         <p:spPr>
           <a:xfrm>
-            <a:off x="3465576" y="2560320"/>
-            <a:ext cx="2377440" cy="502920"/>
+            <a:off x="3465576" y="2551176"/>
+            <a:ext cx="2377440" cy="438912"/>
           </a:xfrm>
           <a:prstGeom prst="rect">
             <a:avLst/>
@@ -6425,7 +6531,7 @@
               <a:buNone/>
             </a:pPr>
             <a:r>
-              <a:rPr lang="en-US" sz="1150" b="1" dirty="0">
+              <a:rPr lang="en-US" sz="1100" b="1" dirty="0">
                 <a:solidFill>
                   <a:srgbClr val="1B3B5F"/>
                 </a:solidFill>
@@ -6433,9 +6539,9 @@
                 <a:ea typeface="Cambria" pitchFamily="34" charset="-122"/>
                 <a:cs typeface="Cambria" pitchFamily="34" charset="-120"/>
               </a:rPr>
-              <a:t>Multi-Agent AI Systems</a:t>
-            </a:r>
-            <a:endParaRPr lang="en-US" sz="1150" dirty="0"/>
+              <a:t>Multi-Agent AI</a:t>
+            </a:r>
+            <a:endParaRPr lang="en-US" sz="1100" dirty="0"/>
           </a:p>
         </p:txBody>
       </p:sp>
@@ -6447,8 +6553,8 @@
         </p:nvSpPr>
         <p:spPr>
           <a:xfrm>
-            <a:off x="3465576" y="3044952"/>
-            <a:ext cx="2377440" cy="530352"/>
+            <a:off x="3465576" y="2971800"/>
+            <a:ext cx="2377440" cy="621792"/>
           </a:xfrm>
           <a:prstGeom prst="rect">
             <a:avLst/>
@@ -6464,7 +6570,7 @@
               <a:buNone/>
             </a:pPr>
             <a:r>
-              <a:rPr lang="en-US" sz="900" dirty="0">
+              <a:rPr lang="en-US" sz="850" dirty="0">
                 <a:solidFill>
                   <a:srgbClr val="5C6B73"/>
                 </a:solidFill>
@@ -6472,9 +6578,26 @@
                 <a:ea typeface="Calibri" pitchFamily="34" charset="-122"/>
                 <a:cs typeface="Calibri" pitchFamily="34" charset="-120"/>
               </a:rPr>
-              <a:t>5-agent architecture + orchestrator</a:t>
-            </a:r>
-            <a:endParaRPr lang="en-US" sz="900" dirty="0"/>
+              <a:t>Custom Python orchestrator (prototype)</a:t>
+            </a:r>
+            <a:endParaRPr lang="en-US" sz="850" dirty="0"/>
+          </a:p>
+          <a:p>
+            <a:pPr marL="0" indent="0" algn="ctr">
+              <a:buNone/>
+            </a:pPr>
+            <a:r>
+              <a:rPr lang="en-US" sz="850" dirty="0">
+                <a:solidFill>
+                  <a:srgbClr val="5C6B73"/>
+                </a:solidFill>
+                <a:latin typeface="Calibri" pitchFamily="34" charset="0"/>
+                <a:ea typeface="Calibri" pitchFamily="34" charset="-122"/>
+                <a:cs typeface="Calibri" pitchFamily="34" charset="-120"/>
+              </a:rPr>
+              <a:t>LangGraph / CrewAI (roadmap)</a:t>
+            </a:r>
+            <a:endParaRPr lang="en-US" sz="850" dirty="0"/>
           </a:p>
         </p:txBody>
       </p:sp>
@@ -6559,8 +6682,8 @@
         </p:nvSpPr>
         <p:spPr>
           <a:xfrm>
-            <a:off x="6227064" y="2560320"/>
-            <a:ext cx="2377440" cy="502920"/>
+            <a:off x="6227064" y="2551176"/>
+            <a:ext cx="2377440" cy="438912"/>
           </a:xfrm>
           <a:prstGeom prst="rect">
             <a:avLst/>
@@ -6576,7 +6699,7 @@
               <a:buNone/>
             </a:pPr>
             <a:r>
-              <a:rPr lang="en-US" sz="1150" b="1" dirty="0">
+              <a:rPr lang="en-US" sz="1100" b="1" dirty="0">
                 <a:solidFill>
                   <a:srgbClr val="1B3B5F"/>
                 </a:solidFill>
@@ -6586,7 +6709,7 @@
               </a:rPr>
               <a:t>Real-Time IoT Integration</a:t>
             </a:r>
-            <a:endParaRPr lang="en-US" sz="1150" dirty="0"/>
+            <a:endParaRPr lang="en-US" sz="1100" dirty="0"/>
           </a:p>
         </p:txBody>
       </p:sp>
@@ -6598,8 +6721,8 @@
         </p:nvSpPr>
         <p:spPr>
           <a:xfrm>
-            <a:off x="6227064" y="3044952"/>
-            <a:ext cx="2377440" cy="530352"/>
+            <a:off x="6227064" y="2971800"/>
+            <a:ext cx="2377440" cy="621792"/>
           </a:xfrm>
           <a:prstGeom prst="rect">
             <a:avLst/>
@@ -6615,7 +6738,7 @@
               <a:buNone/>
             </a:pPr>
             <a:r>
-              <a:rPr lang="en-US" sz="900" dirty="0">
+              <a:rPr lang="en-US" sz="850" dirty="0">
                 <a:solidFill>
                   <a:srgbClr val="5C6B73"/>
                 </a:solidFill>
@@ -6623,9 +6746,9 @@
                 <a:ea typeface="Calibri" pitchFamily="34" charset="-122"/>
                 <a:cs typeface="Calibri" pitchFamily="34" charset="-120"/>
               </a:rPr>
-              <a:t>Hourly CAAQMS ingestion, 40+ stations</a:t>
-            </a:r>
-            <a:endParaRPr lang="en-US" sz="900" dirty="0"/>
+              <a:t>OpenAQ v3 API • Open-Meteo • 40+ CAAQMS stations</a:t>
+            </a:r>
+            <a:endParaRPr lang="en-US" sz="850" dirty="0"/>
           </a:p>
         </p:txBody>
       </p:sp>
@@ -6710,8 +6833,8 @@
         </p:nvSpPr>
         <p:spPr>
           <a:xfrm>
-            <a:off x="8988552" y="2560320"/>
-            <a:ext cx="2377440" cy="502920"/>
+            <a:off x="8988552" y="2551176"/>
+            <a:ext cx="2377440" cy="438912"/>
           </a:xfrm>
           <a:prstGeom prst="rect">
             <a:avLst/>
@@ -6727,7 +6850,7 @@
               <a:buNone/>
             </a:pPr>
             <a:r>
-              <a:rPr lang="en-US" sz="1150" b="1" dirty="0">
+              <a:rPr lang="en-US" sz="1100" b="1" dirty="0">
                 <a:solidFill>
                   <a:srgbClr val="1B3B5F"/>
                 </a:solidFill>
@@ -6735,9 +6858,9 @@
                 <a:ea typeface="Cambria" pitchFamily="34" charset="-122"/>
                 <a:cs typeface="Cambria" pitchFamily="34" charset="-120"/>
               </a:rPr>
-              <a:t>Atmospheric Dispersion Modelling</a:t>
-            </a:r>
-            <a:endParaRPr lang="en-US" sz="1150" dirty="0"/>
+              <a:t>Atmospheric Dispersion</a:t>
+            </a:r>
+            <a:endParaRPr lang="en-US" sz="1100" dirty="0"/>
           </a:p>
         </p:txBody>
       </p:sp>
@@ -6749,8 +6872,8 @@
         </p:nvSpPr>
         <p:spPr>
           <a:xfrm>
-            <a:off x="8988552" y="3044952"/>
-            <a:ext cx="2377440" cy="530352"/>
+            <a:off x="8988552" y="2971800"/>
+            <a:ext cx="2377440" cy="621792"/>
           </a:xfrm>
           <a:prstGeom prst="rect">
             <a:avLst/>
@@ -6766,7 +6889,7 @@
               <a:buNone/>
             </a:pPr>
             <a:r>
-              <a:rPr lang="en-US" sz="900" dirty="0">
+              <a:rPr lang="en-US" sz="850" dirty="0">
                 <a:solidFill>
                   <a:srgbClr val="5C6B73"/>
                 </a:solidFill>
@@ -6774,9 +6897,9 @@
                 <a:ea typeface="Calibri" pitchFamily="34" charset="-122"/>
                 <a:cs typeface="Calibri" pitchFamily="34" charset="-120"/>
               </a:rPr>
-              <a:t>Gaussian-plume model blended with GNN</a:t>
-            </a:r>
-            <a:endParaRPr lang="en-US" sz="900" dirty="0"/>
+              <a:t>Gaussian-plume model blended with GBR forecast</a:t>
+            </a:r>
+            <a:endParaRPr lang="en-US" sz="850" dirty="0"/>
           </a:p>
         </p:txBody>
       </p:sp>
@@ -6861,8 +6984,8 @@
         </p:nvSpPr>
         <p:spPr>
           <a:xfrm>
-            <a:off x="704088" y="4572000"/>
-            <a:ext cx="2377440" cy="502920"/>
+            <a:off x="704088" y="4562856"/>
+            <a:ext cx="2377440" cy="438912"/>
           </a:xfrm>
           <a:prstGeom prst="rect">
             <a:avLst/>
@@ -6878,7 +7001,7 @@
               <a:buNone/>
             </a:pPr>
             <a:r>
-              <a:rPr lang="en-US" sz="1150" b="1" dirty="0">
+              <a:rPr lang="en-US" sz="1100" b="1" dirty="0">
                 <a:solidFill>
                   <a:srgbClr val="1B3B5F"/>
                 </a:solidFill>
@@ -6888,7 +7011,7 @@
               </a:rPr>
               <a:t>Predictive Analytics</a:t>
             </a:r>
-            <a:endParaRPr lang="en-US" sz="1150" dirty="0"/>
+            <a:endParaRPr lang="en-US" sz="1100" dirty="0"/>
           </a:p>
         </p:txBody>
       </p:sp>
@@ -6900,8 +7023,8 @@
         </p:nvSpPr>
         <p:spPr>
           <a:xfrm>
-            <a:off x="704088" y="5056632"/>
-            <a:ext cx="2377440" cy="530352"/>
+            <a:off x="704088" y="4983480"/>
+            <a:ext cx="2377440" cy="621792"/>
           </a:xfrm>
           <a:prstGeom prst="rect">
             <a:avLst/>
@@ -6917,7 +7040,7 @@
               <a:buNone/>
             </a:pPr>
             <a:r>
-              <a:rPr lang="en-US" sz="900" dirty="0">
+              <a:rPr lang="en-US" sz="850" dirty="0">
                 <a:solidFill>
                   <a:srgbClr val="5C6B73"/>
                 </a:solidFill>
@@ -6925,9 +7048,26 @@
                 <a:ea typeface="Calibri" pitchFamily="34" charset="-122"/>
                 <a:cs typeface="Calibri" pitchFamily="34" charset="-120"/>
               </a:rPr>
-              <a:t>Graph Neural Network + time-series</a:t>
-            </a:r>
-            <a:endParaRPr lang="en-US" sz="900" dirty="0"/>
+              <a:t>scikit-learn GradientBoostingRegressor (prototype)</a:t>
+            </a:r>
+            <a:endParaRPr lang="en-US" sz="850" dirty="0"/>
+          </a:p>
+          <a:p>
+            <a:pPr marL="0" indent="0" algn="ctr">
+              <a:buNone/>
+            </a:pPr>
+            <a:r>
+              <a:rPr lang="en-US" sz="850" dirty="0">
+                <a:solidFill>
+                  <a:srgbClr val="5C6B73"/>
+                </a:solidFill>
+                <a:latin typeface="Calibri" pitchFamily="34" charset="0"/>
+                <a:ea typeface="Calibri" pitchFamily="34" charset="-122"/>
+                <a:cs typeface="Calibri" pitchFamily="34" charset="-120"/>
+              </a:rPr>
+              <a:t>PyTorch Geometric GNN (roadmap)</a:t>
+            </a:r>
+            <a:endParaRPr lang="en-US" sz="850" dirty="0"/>
           </a:p>
         </p:txBody>
       </p:sp>
@@ -7012,8 +7152,8 @@
         </p:nvSpPr>
         <p:spPr>
           <a:xfrm>
-            <a:off x="3465576" y="4572000"/>
-            <a:ext cx="2377440" cy="502920"/>
+            <a:off x="3465576" y="4562856"/>
+            <a:ext cx="2377440" cy="438912"/>
           </a:xfrm>
           <a:prstGeom prst="rect">
             <a:avLst/>
@@ -7029,7 +7169,7 @@
               <a:buNone/>
             </a:pPr>
             <a:r>
-              <a:rPr lang="en-US" sz="1150" b="1" dirty="0">
+              <a:rPr lang="en-US" sz="1100" b="1" dirty="0">
                 <a:solidFill>
                   <a:srgbClr val="1B3B5F"/>
                 </a:solidFill>
@@ -7039,7 +7179,7 @@
               </a:rPr>
               <a:t>Causal Inference</a:t>
             </a:r>
-            <a:endParaRPr lang="en-US" sz="1150" dirty="0"/>
+            <a:endParaRPr lang="en-US" sz="1100" dirty="0"/>
           </a:p>
         </p:txBody>
       </p:sp>
@@ -7051,8 +7191,8 @@
         </p:nvSpPr>
         <p:spPr>
           <a:xfrm>
-            <a:off x="3465576" y="5056632"/>
-            <a:ext cx="2377440" cy="530352"/>
+            <a:off x="3465576" y="4983480"/>
+            <a:ext cx="2377440" cy="621792"/>
           </a:xfrm>
           <a:prstGeom prst="rect">
             <a:avLst/>
@@ -7068,7 +7208,7 @@
               <a:buNone/>
             </a:pPr>
             <a:r>
-              <a:rPr lang="en-US" sz="900" dirty="0">
+              <a:rPr lang="en-US" sz="850" dirty="0">
                 <a:solidFill>
                   <a:srgbClr val="5C6B73"/>
                 </a:solidFill>
@@ -7076,9 +7216,9 @@
                 <a:ea typeface="Calibri" pitchFamily="34" charset="-122"/>
                 <a:cs typeface="Calibri" pitchFamily="34" charset="-120"/>
               </a:rPr>
-              <a:t>Confounder-aware source attribution</a:t>
-            </a:r>
-            <a:endParaRPr lang="en-US" sz="900" dirty="0"/>
+              <a:t>Cosine-similarity fingerprint + wind confounder adjustment</a:t>
+            </a:r>
+            <a:endParaRPr lang="en-US" sz="850" dirty="0"/>
           </a:p>
         </p:txBody>
       </p:sp>
@@ -7163,8 +7303,8 @@
         </p:nvSpPr>
         <p:spPr>
           <a:xfrm>
-            <a:off x="6227064" y="4572000"/>
-            <a:ext cx="2377440" cy="502920"/>
+            <a:off x="6227064" y="4562856"/>
+            <a:ext cx="2377440" cy="438912"/>
           </a:xfrm>
           <a:prstGeom prst="rect">
             <a:avLst/>
@@ -7180,7 +7320,7 @@
               <a:buNone/>
             </a:pPr>
             <a:r>
-              <a:rPr lang="en-US" sz="1150" b="1" dirty="0">
+              <a:rPr lang="en-US" sz="1100" b="1" dirty="0">
                 <a:solidFill>
                   <a:srgbClr val="1B3B5F"/>
                 </a:solidFill>
@@ -7190,7 +7330,7 @@
               </a:rPr>
               <a:t>LLMs, Multi-Language</a:t>
             </a:r>
-            <a:endParaRPr lang="en-US" sz="1150" dirty="0"/>
+            <a:endParaRPr lang="en-US" sz="1100" dirty="0"/>
           </a:p>
         </p:txBody>
       </p:sp>
@@ -7202,8 +7342,8 @@
         </p:nvSpPr>
         <p:spPr>
           <a:xfrm>
-            <a:off x="6227064" y="5056632"/>
-            <a:ext cx="2377440" cy="530352"/>
+            <a:off x="6227064" y="4983480"/>
+            <a:ext cx="2377440" cy="621792"/>
           </a:xfrm>
           <a:prstGeom prst="rect">
             <a:avLst/>
@@ -7219,7 +7359,7 @@
               <a:buNone/>
             </a:pPr>
             <a:r>
-              <a:rPr lang="en-US" sz="900" dirty="0">
+              <a:rPr lang="en-US" sz="850" dirty="0">
                 <a:solidFill>
                   <a:srgbClr val="5C6B73"/>
                 </a:solidFill>
@@ -7227,9 +7367,9 @@
                 <a:ea typeface="Calibri" pitchFamily="34" charset="-122"/>
                 <a:cs typeface="Calibri" pitchFamily="34" charset="-120"/>
               </a:rPr>
-              <a:t>Regional-language citizen advisories</a:t>
-            </a:r>
-            <a:endParaRPr lang="en-US" sz="900" dirty="0"/>
+              <a:t>Template-based (prototype) · Anthropic Claude API (roadmap)</a:t>
+            </a:r>
+            <a:endParaRPr lang="en-US" sz="850" dirty="0"/>
           </a:p>
         </p:txBody>
       </p:sp>
@@ -7314,8 +7454,8 @@
         </p:nvSpPr>
         <p:spPr>
           <a:xfrm>
-            <a:off x="8988552" y="4572000"/>
-            <a:ext cx="2377440" cy="502920"/>
+            <a:off x="8988552" y="4562856"/>
+            <a:ext cx="2377440" cy="438912"/>
           </a:xfrm>
           <a:prstGeom prst="rect">
             <a:avLst/>
@@ -7331,7 +7471,7 @@
               <a:buNone/>
             </a:pPr>
             <a:r>
-              <a:rPr lang="en-US" sz="1150" b="1" dirty="0">
+              <a:rPr lang="en-US" sz="1100" b="1" dirty="0">
                 <a:solidFill>
                   <a:srgbClr val="1B3B5F"/>
                 </a:solidFill>
@@ -7339,9 +7479,9 @@
                 <a:ea typeface="Cambria" pitchFamily="34" charset="-122"/>
                 <a:cs typeface="Cambria" pitchFamily="34" charset="-120"/>
               </a:rPr>
-              <a:t>Geospatial Data Layer</a:t>
-            </a:r>
-            <a:endParaRPr lang="en-US" sz="1150" dirty="0"/>
+              <a:t>Frontend &amp; Data</a:t>
+            </a:r>
+            <a:endParaRPr lang="en-US" sz="1100" dirty="0"/>
           </a:p>
         </p:txBody>
       </p:sp>
@@ -7353,8 +7493,8 @@
         </p:nvSpPr>
         <p:spPr>
           <a:xfrm>
-            <a:off x="8988552" y="5056632"/>
-            <a:ext cx="2377440" cy="530352"/>
+            <a:off x="8988552" y="4983480"/>
+            <a:ext cx="2377440" cy="621792"/>
           </a:xfrm>
           <a:prstGeom prst="rect">
             <a:avLst/>
@@ -7370,7 +7510,7 @@
               <a:buNone/>
             </a:pPr>
             <a:r>
-              <a:rPr lang="en-US" sz="900" dirty="0">
+              <a:rPr lang="en-US" sz="850" dirty="0">
                 <a:solidFill>
                   <a:srgbClr val="5C6B73"/>
                 </a:solidFill>
@@ -7378,7 +7518,85 @@
                 <a:ea typeface="Calibri" pitchFamily="34" charset="-122"/>
                 <a:cs typeface="Calibri" pitchFamily="34" charset="-120"/>
               </a:rPr>
-              <a:t>Ward boundaries, land use, population</a:t>
+              <a:t>Streamlit + Plotly + pandas/Parquet (live, running)</a:t>
+            </a:r>
+            <a:endParaRPr lang="en-US" sz="850" dirty="0"/>
+          </a:p>
+        </p:txBody>
+      </p:sp>
+      <p:sp>
+        <p:nvSpPr>
+          <p:cNvPr id="44" name="Text 34"/>
+          <p:cNvSpPr/>
+          <p:nvPr/>
+        </p:nvSpPr>
+        <p:spPr>
+          <a:xfrm>
+            <a:off x="11002975" y="6419088"/>
+            <a:ext cx="822960" cy="274320"/>
+          </a:xfrm>
+          <a:prstGeom prst="rect">
+            <a:avLst/>
+          </a:prstGeom>
+          <a:noFill/>
+          <a:ln/>
+        </p:spPr>
+        <p:txBody>
+          <a:bodyPr wrap="square" lIns="0" tIns="0" rIns="0" bIns="0" rtlCol="0" anchor="ctr"/>
+          <a:lstStyle/>
+          <a:p>
+            <a:pPr marL="0" indent="0" algn="r">
+              <a:buNone/>
+            </a:pPr>
+            <a:r>
+              <a:rPr lang="en-US" sz="900" dirty="0">
+                <a:solidFill>
+                  <a:srgbClr val="5C6B73"/>
+                </a:solidFill>
+                <a:latin typeface="Calibri" pitchFamily="34" charset="0"/>
+                <a:ea typeface="Calibri" pitchFamily="34" charset="-122"/>
+                <a:cs typeface="Calibri" pitchFamily="34" charset="-120"/>
+              </a:rPr>
+              <a:t>12 / 16</a:t>
+            </a:r>
+            <a:endParaRPr lang="en-US" sz="900" dirty="0"/>
+          </a:p>
+        </p:txBody>
+      </p:sp>
+      <p:sp>
+        <p:nvSpPr>
+          <p:cNvPr id="45" name="Text 35"/>
+          <p:cNvSpPr/>
+          <p:nvPr/>
+        </p:nvSpPr>
+        <p:spPr>
+          <a:xfrm>
+            <a:off x="594360" y="6419088"/>
+            <a:ext cx="4572000" cy="274320"/>
+          </a:xfrm>
+          <a:prstGeom prst="rect">
+            <a:avLst/>
+          </a:prstGeom>
+          <a:noFill/>
+          <a:ln/>
+        </p:spPr>
+        <p:txBody>
+          <a:bodyPr wrap="square" lIns="0" tIns="0" rIns="0" bIns="0" rtlCol="0" anchor="ctr"/>
+          <a:lstStyle/>
+          <a:p>
+            <a:pPr marL="0" indent="0">
+              <a:buNone/>
+            </a:pPr>
+            <a:r>
+              <a:rPr lang="en-US" sz="900" dirty="0">
+                <a:solidFill>
+                  <a:srgbClr val="5C6B73"/>
+                </a:solidFill>
+                <a:latin typeface="Calibri" pitchFamily="34" charset="0"/>
+                <a:ea typeface="Calibri" pitchFamily="34" charset="-122"/>
+                <a:cs typeface="Calibri" pitchFamily="34" charset="-120"/>
+              </a:rPr>
+              <a:t>PRAANA — ET AI Hackathon 2026</a:t>
             </a:r>
             <a:endParaRPr lang="en-US" sz="900" dirty="0"/>
           </a:p>
@@ -7489,7 +7707,7 @@
                 <a:ea typeface="Cambria" pitchFamily="34" charset="-122"/>
                 <a:cs typeface="Cambria" pitchFamily="34" charset="-120"/>
               </a:rPr>
-              <a:t>How We Prove It Works</a:t>
+              <a:t>How We Prove It Works — Including Real Numbers</a:t>
             </a:r>
             <a:endParaRPr lang="en-US" sz="2800" dirty="0"/>
           </a:p>
@@ -7503,7 +7721,7 @@
         </p:nvSpPr>
         <p:spPr>
           <a:xfrm>
-            <a:off x="594360" y="1691640"/>
+            <a:off x="594360" y="1719072"/>
             <a:ext cx="11002975" cy="777240"/>
           </a:xfrm>
           <a:prstGeom prst="roundRect">
@@ -7532,7 +7750,7 @@
         </p:nvSpPr>
         <p:spPr>
           <a:xfrm>
-            <a:off x="758952" y="1810512"/>
+            <a:off x="758952" y="1828800"/>
             <a:ext cx="548640" cy="548640"/>
           </a:xfrm>
           <a:prstGeom prst="rect">
@@ -7571,8 +7789,8 @@
         </p:nvSpPr>
         <p:spPr>
           <a:xfrm>
-            <a:off x="1463040" y="1737360"/>
-            <a:ext cx="4206240" cy="685800"/>
+            <a:off x="1463040" y="1764792"/>
+            <a:ext cx="3657600" cy="685800"/>
           </a:xfrm>
           <a:prstGeom prst="rect">
             <a:avLst/>
@@ -7588,7 +7806,7 @@
               <a:buNone/>
             </a:pPr>
             <a:r>
-              <a:rPr lang="en-US" sz="1300" b="1" dirty="0">
+              <a:rPr lang="en-US" sz="1250" b="1" dirty="0">
                 <a:solidFill>
                   <a:srgbClr val="1B3B5F"/>
                 </a:solidFill>
@@ -7598,7 +7816,7 @@
               </a:rPr>
               <a:t>Source attribution accuracy</a:t>
             </a:r>
-            <a:endParaRPr lang="en-US" sz="1300" dirty="0"/>
+            <a:endParaRPr lang="en-US" sz="1250" dirty="0"/>
           </a:p>
         </p:txBody>
       </p:sp>
@@ -7610,8 +7828,8 @@
         </p:nvSpPr>
         <p:spPr>
           <a:xfrm>
-            <a:off x="5806440" y="1737360"/>
-            <a:ext cx="5653735" cy="685800"/>
+            <a:off x="5257800" y="1764792"/>
+            <a:ext cx="6202375" cy="685800"/>
           </a:xfrm>
           <a:prstGeom prst="rect">
             <a:avLst/>
@@ -7635,7 +7853,7 @@
                 <a:ea typeface="Calibri" pitchFamily="34" charset="-122"/>
                 <a:cs typeface="Calibri" pitchFamily="34" charset="-120"/>
               </a:rPr>
-              <a:t>Benchmarked vs. IIT-K / CPCB source-apportionment ground truth</a:t>
+              <a:t>Benchmarked vs. IIT-K / CPCB source-apportionment ground truth per source category</a:t>
             </a:r>
             <a:endParaRPr lang="en-US" sz="1100" dirty="0"/>
           </a:p>
@@ -7649,16 +7867,16 @@
         </p:nvSpPr>
         <p:spPr>
           <a:xfrm>
-            <a:off x="594360" y="2560320"/>
-            <a:ext cx="11002975" cy="777240"/>
+            <a:off x="594360" y="2569464"/>
+            <a:ext cx="11002975" cy="1005840"/>
           </a:xfrm>
           <a:prstGeom prst="roundRect">
             <a:avLst>
-              <a:gd name="adj" fmla="val 10588"/>
+              <a:gd name="adj" fmla="val 8182"/>
             </a:avLst>
           </a:prstGeom>
           <a:solidFill>
-            <a:srgbClr val="FFFFFF"/>
+            <a:srgbClr val="F0F8FF"/>
           </a:solidFill>
           <a:ln/>
           <a:effectLst>
@@ -7697,7 +7915,7 @@
             <a:r>
               <a:rPr lang="en-US" sz="2000" b="1" dirty="0">
                 <a:solidFill>
-                  <a:srgbClr val="E8862E"/>
+                  <a:srgbClr val="1B3B5F"/>
                 </a:solidFill>
                 <a:latin typeface="Cambria" pitchFamily="34" charset="0"/>
                 <a:ea typeface="Cambria" pitchFamily="34" charset="-122"/>
@@ -7717,8 +7935,8 @@
         </p:nvSpPr>
         <p:spPr>
           <a:xfrm>
-            <a:off x="1463040" y="2606040"/>
-            <a:ext cx="4206240" cy="685800"/>
+            <a:off x="1463040" y="2615184"/>
+            <a:ext cx="3657600" cy="914400"/>
           </a:xfrm>
           <a:prstGeom prst="rect">
             <a:avLst/>
@@ -7734,7 +7952,7 @@
               <a:buNone/>
             </a:pPr>
             <a:r>
-              <a:rPr lang="en-US" sz="1300" b="1" dirty="0">
+              <a:rPr lang="en-US" sz="1250" b="1" dirty="0">
                 <a:solidFill>
                   <a:srgbClr val="1B3B5F"/>
                 </a:solidFill>
@@ -7742,9 +7960,9 @@
                 <a:ea typeface="Cambria" pitchFamily="34" charset="-122"/>
                 <a:cs typeface="Cambria" pitchFamily="34" charset="-120"/>
               </a:rPr>
-              <a:t>Forecast accuracy (RMSE)</a:t>
-            </a:r>
-            <a:endParaRPr lang="en-US" sz="1300" dirty="0"/>
+              <a:t>Forecast accuracy — ACTUAL RMSE</a:t>
+            </a:r>
+            <a:endParaRPr lang="en-US" sz="1250" dirty="0"/>
           </a:p>
         </p:txBody>
       </p:sp>
@@ -7756,8 +7974,8 @@
         </p:nvSpPr>
         <p:spPr>
           <a:xfrm>
-            <a:off x="5806440" y="2606040"/>
-            <a:ext cx="5653735" cy="685800"/>
+            <a:off x="5257800" y="2615184"/>
+            <a:ext cx="6202375" cy="914400"/>
           </a:xfrm>
           <a:prstGeom prst="rect">
             <a:avLst/>
@@ -7773,17 +7991,34 @@
               <a:buNone/>
             </a:pPr>
             <a:r>
-              <a:rPr lang="en-US" sz="1100" dirty="0">
-                <a:solidFill>
-                  <a:srgbClr val="1F2A33"/>
+              <a:rPr lang="en-US" sz="1050" dirty="0">
+                <a:solidFill>
+                  <a:srgbClr val="1B3B5F"/>
                 </a:solidFill>
                 <a:latin typeface="Calibri" pitchFamily="34" charset="0"/>
                 <a:ea typeface="Calibri" pitchFamily="34" charset="-122"/>
                 <a:cs typeface="Calibri" pitchFamily="34" charset="-120"/>
               </a:rPr>
-              <a:t>vs. persistence baseline, at 24 / 48 / 72hr horizons, by season</a:t>
-            </a:r>
-            <a:endParaRPr lang="en-US" sz="1100" dirty="0"/>
+              <a:t>24h: 78.5 vs baseline 112.9 (30.5% better) • 48h: 78.5 vs 114.3 (31.3%) • 72h: 78.5 vs 114.2 (31.3%)</a:t>
+            </a:r>
+            <a:endParaRPr lang="en-US" sz="1050" dirty="0"/>
+          </a:p>
+          <a:p>
+            <a:pPr marL="0" indent="0">
+              <a:buNone/>
+            </a:pPr>
+            <a:r>
+              <a:rPr lang="en-US" sz="1050" dirty="0">
+                <a:solidFill>
+                  <a:srgbClr val="1B3B5F"/>
+                </a:solidFill>
+                <a:latin typeface="Calibri" pitchFamily="34" charset="0"/>
+                <a:ea typeface="Calibri" pitchFamily="34" charset="-122"/>
+                <a:cs typeface="Calibri" pitchFamily="34" charset="-120"/>
+              </a:rPr>
+              <a:t>Model: scikit-learn GBR, trained 2019–2023, tested on held-out 2024 data (8,760 hourly rows)</a:t>
+            </a:r>
+            <a:endParaRPr lang="en-US" sz="1050" dirty="0"/>
           </a:p>
         </p:txBody>
       </p:sp>
@@ -7795,7 +8030,7 @@
         </p:nvSpPr>
         <p:spPr>
           <a:xfrm>
-            <a:off x="594360" y="3429000"/>
+            <a:off x="594360" y="3648456"/>
             <a:ext cx="11002975" cy="777240"/>
           </a:xfrm>
           <a:prstGeom prst="roundRect">
@@ -7824,7 +8059,7 @@
         </p:nvSpPr>
         <p:spPr>
           <a:xfrm>
-            <a:off x="758952" y="3547872"/>
+            <a:off x="758952" y="3758184"/>
             <a:ext cx="548640" cy="548640"/>
           </a:xfrm>
           <a:prstGeom prst="rect">
@@ -7863,8 +8098,8 @@
         </p:nvSpPr>
         <p:spPr>
           <a:xfrm>
-            <a:off x="1463040" y="3474720"/>
-            <a:ext cx="4206240" cy="685800"/>
+            <a:off x="1463040" y="3694176"/>
+            <a:ext cx="3657600" cy="685800"/>
           </a:xfrm>
           <a:prstGeom prst="rect">
             <a:avLst/>
@@ -7880,7 +8115,7 @@
               <a:buNone/>
             </a:pPr>
             <a:r>
-              <a:rPr lang="en-US" sz="1300" b="1" dirty="0">
+              <a:rPr lang="en-US" sz="1250" b="1" dirty="0">
                 <a:solidFill>
                   <a:srgbClr val="1B3B5F"/>
                 </a:solidFill>
@@ -7890,7 +8125,7 @@
               </a:rPr>
               <a:t>Enforcement recommendation quality</a:t>
             </a:r>
-            <a:endParaRPr lang="en-US" sz="1300" dirty="0"/>
+            <a:endParaRPr lang="en-US" sz="1250" dirty="0"/>
           </a:p>
         </p:txBody>
       </p:sp>
@@ -7902,8 +8137,8 @@
         </p:nvSpPr>
         <p:spPr>
           <a:xfrm>
-            <a:off x="5806440" y="3474720"/>
-            <a:ext cx="5653735" cy="685800"/>
+            <a:off x="5257800" y="3694176"/>
+            <a:ext cx="6202375" cy="685800"/>
           </a:xfrm>
           <a:prstGeom prst="rect">
             <a:avLst/>
@@ -7927,7 +8162,7 @@
                 <a:ea typeface="Calibri" pitchFamily="34" charset="-122"/>
                 <a:cs typeface="Calibri" pitchFamily="34" charset="-120"/>
               </a:rPr>
-              <a:t>Rated by domain experts against the evidence trail provided</a:t>
+              <a:t>Rated by domain experts against the evidence trail — 1–5 relevance &amp; feasibility scale</a:t>
             </a:r>
             <a:endParaRPr lang="en-US" sz="1100" dirty="0"/>
           </a:p>
@@ -7941,7 +8176,7 @@
         </p:nvSpPr>
         <p:spPr>
           <a:xfrm>
-            <a:off x="594360" y="4297680"/>
+            <a:off x="594360" y="4498848"/>
             <a:ext cx="11002975" cy="777240"/>
           </a:xfrm>
           <a:prstGeom prst="roundRect">
@@ -7970,7 +8205,7 @@
         </p:nvSpPr>
         <p:spPr>
           <a:xfrm>
-            <a:off x="758952" y="4416552"/>
+            <a:off x="758952" y="4608576"/>
             <a:ext cx="548640" cy="548640"/>
           </a:xfrm>
           <a:prstGeom prst="rect">
@@ -8009,8 +8244,8 @@
         </p:nvSpPr>
         <p:spPr>
           <a:xfrm>
-            <a:off x="1463040" y="4343400"/>
-            <a:ext cx="4206240" cy="685800"/>
+            <a:off x="1463040" y="4544568"/>
+            <a:ext cx="3657600" cy="685800"/>
           </a:xfrm>
           <a:prstGeom prst="rect">
             <a:avLst/>
@@ -8026,7 +8261,7 @@
               <a:buNone/>
             </a:pPr>
             <a:r>
-              <a:rPr lang="en-US" sz="1300" b="1" dirty="0">
+              <a:rPr lang="en-US" sz="1250" b="1" dirty="0">
                 <a:solidFill>
                   <a:srgbClr val="1B3B5F"/>
                 </a:solidFill>
@@ -8036,7 +8271,7 @@
               </a:rPr>
               <a:t>Advisory relevance &amp; language coverage</a:t>
             </a:r>
-            <a:endParaRPr lang="en-US" sz="1300" dirty="0"/>
+            <a:endParaRPr lang="en-US" sz="1250" dirty="0"/>
           </a:p>
         </p:txBody>
       </p:sp>
@@ -8048,8 +8283,8 @@
         </p:nvSpPr>
         <p:spPr>
           <a:xfrm>
-            <a:off x="5806440" y="4343400"/>
-            <a:ext cx="5653735" cy="685800"/>
+            <a:off x="5257800" y="4544568"/>
+            <a:ext cx="6202375" cy="685800"/>
           </a:xfrm>
           <a:prstGeom prst="rect">
             <a:avLst/>
@@ -8073,7 +8308,7 @@
                 <a:ea typeface="Calibri" pitchFamily="34" charset="-122"/>
                 <a:cs typeface="Calibri" pitchFamily="34" charset="-120"/>
               </a:rPr>
-              <a:t>Severity-match rate + languages live, validated by native speakers</a:t>
+              <a:t>Severity-match rate + 5 languages validated by native speakers</a:t>
             </a:r>
             <a:endParaRPr lang="en-US" sz="1100" dirty="0"/>
           </a:p>
@@ -8087,7 +8322,7 @@
         </p:nvSpPr>
         <p:spPr>
           <a:xfrm>
-            <a:off x="594360" y="5166360"/>
+            <a:off x="594360" y="5349240"/>
             <a:ext cx="11002975" cy="777240"/>
           </a:xfrm>
           <a:prstGeom prst="roundRect">
@@ -8116,7 +8351,7 @@
         </p:nvSpPr>
         <p:spPr>
           <a:xfrm>
-            <a:off x="758952" y="5285232"/>
+            <a:off x="758952" y="5458968"/>
             <a:ext cx="548640" cy="548640"/>
           </a:xfrm>
           <a:prstGeom prst="rect">
@@ -8155,8 +8390,8 @@
         </p:nvSpPr>
         <p:spPr>
           <a:xfrm>
-            <a:off x="1463040" y="5212080"/>
-            <a:ext cx="4206240" cy="685800"/>
+            <a:off x="1463040" y="5394960"/>
+            <a:ext cx="3657600" cy="685800"/>
           </a:xfrm>
           <a:prstGeom prst="rect">
             <a:avLst/>
@@ -8172,7 +8407,7 @@
               <a:buNone/>
             </a:pPr>
             <a:r>
-              <a:rPr lang="en-US" sz="1300" b="1" dirty="0">
+              <a:rPr lang="en-US" sz="1250" b="1" dirty="0">
                 <a:solidFill>
                   <a:srgbClr val="1B3B5F"/>
                 </a:solidFill>
@@ -8182,7 +8417,7 @@
               </a:rPr>
               <a:t>Response-time reduction</a:t>
             </a:r>
-            <a:endParaRPr lang="en-US" sz="1300" dirty="0"/>
+            <a:endParaRPr lang="en-US" sz="1250" dirty="0"/>
           </a:p>
         </p:txBody>
       </p:sp>
@@ -8194,8 +8429,8 @@
         </p:nvSpPr>
         <p:spPr>
           <a:xfrm>
-            <a:off x="5806440" y="5212080"/>
-            <a:ext cx="5653735" cy="685800"/>
+            <a:off x="5257800" y="5394960"/>
+            <a:ext cx="6202375" cy="685800"/>
           </a:xfrm>
           <a:prstGeom prst="rect">
             <a:avLst/>
@@ -8222,6 +8457,84 @@
               <a:t>Signal-to-intervention time vs. documented baseline in pilot wards</a:t>
             </a:r>
             <a:endParaRPr lang="en-US" sz="1100" dirty="0"/>
+          </a:p>
+        </p:txBody>
+      </p:sp>
+      <p:sp>
+        <p:nvSpPr>
+          <p:cNvPr id="24" name="Text 22"/>
+          <p:cNvSpPr/>
+          <p:nvPr/>
+        </p:nvSpPr>
+        <p:spPr>
+          <a:xfrm>
+            <a:off x="11002975" y="6419088"/>
+            <a:ext cx="822960" cy="274320"/>
+          </a:xfrm>
+          <a:prstGeom prst="rect">
+            <a:avLst/>
+          </a:prstGeom>
+          <a:noFill/>
+          <a:ln/>
+        </p:spPr>
+        <p:txBody>
+          <a:bodyPr wrap="square" lIns="0" tIns="0" rIns="0" bIns="0" rtlCol="0" anchor="ctr"/>
+          <a:lstStyle/>
+          <a:p>
+            <a:pPr marL="0" indent="0" algn="r">
+              <a:buNone/>
+            </a:pPr>
+            <a:r>
+              <a:rPr lang="en-US" sz="900" dirty="0">
+                <a:solidFill>
+                  <a:srgbClr val="5C6B73"/>
+                </a:solidFill>
+                <a:latin typeface="Calibri" pitchFamily="34" charset="0"/>
+                <a:ea typeface="Calibri" pitchFamily="34" charset="-122"/>
+                <a:cs typeface="Calibri" pitchFamily="34" charset="-120"/>
+              </a:rPr>
+              <a:t>13 / 16</a:t>
+            </a:r>
+            <a:endParaRPr lang="en-US" sz="900" dirty="0"/>
+          </a:p>
+        </p:txBody>
+      </p:sp>
+      <p:sp>
+        <p:nvSpPr>
+          <p:cNvPr id="25" name="Text 23"/>
+          <p:cNvSpPr/>
+          <p:nvPr/>
+        </p:nvSpPr>
+        <p:spPr>
+          <a:xfrm>
+            <a:off x="594360" y="6419088"/>
+            <a:ext cx="4572000" cy="274320"/>
+          </a:xfrm>
+          <a:prstGeom prst="rect">
+            <a:avLst/>
+          </a:prstGeom>
+          <a:noFill/>
+          <a:ln/>
+        </p:spPr>
+        <p:txBody>
+          <a:bodyPr wrap="square" lIns="0" tIns="0" rIns="0" bIns="0" rtlCol="0" anchor="ctr"/>
+          <a:lstStyle/>
+          <a:p>
+            <a:pPr marL="0" indent="0">
+              <a:buNone/>
+            </a:pPr>
+            <a:r>
+              <a:rPr lang="en-US" sz="900" dirty="0">
+                <a:solidFill>
+                  <a:srgbClr val="5C6B73"/>
+                </a:solidFill>
+                <a:latin typeface="Calibri" pitchFamily="34" charset="0"/>
+                <a:ea typeface="Calibri" pitchFamily="34" charset="-122"/>
+                <a:cs typeface="Calibri" pitchFamily="34" charset="-120"/>
+              </a:rPr>
+              <a:t>PRAANA — ET AI Hackathon 2026</a:t>
+            </a:r>
+            <a:endParaRPr lang="en-US" sz="900" dirty="0"/>
           </a:p>
         </p:txBody>
       </p:sp>
@@ -8453,7 +8766,7 @@
                 <a:ea typeface="Calibri" pitchFamily="34" charset="-122"/>
                 <a:cs typeface="Calibri" pitchFamily="34" charset="-120"/>
               </a:rPr>
-              <a:t>Fingerprint + causal-AI attribution; purpose-built multi-agent design.</a:t>
+              <a:t>Fingerprint + causal-AI attribution; IITM-DSS and SAFAR acknowledged — PRAANA's gap is ward-level enforcement prioritisation + cross-city learning.</a:t>
             </a:r>
             <a:endParaRPr lang="en-US" sz="1050" dirty="0"/>
           </a:p>
@@ -8531,7 +8844,7 @@
                 <a:ea typeface="Calibri" pitchFamily="34" charset="-122"/>
                 <a:cs typeface="Calibri" pitchFamily="34" charset="-120"/>
               </a:rPr>
-              <a:t>Closes the CAG-identified 31% gap with an auditable action trail.</a:t>
+              <a:t>Closes the CAG-identified 31% gap with a measurable, auditable action trail.</a:t>
             </a:r>
             <a:endParaRPr lang="en-US" sz="1050" dirty="0"/>
           </a:p>
@@ -8609,7 +8922,7 @@
                 <a:ea typeface="Calibri" pitchFamily="34" charset="-122"/>
                 <a:cs typeface="Calibri" pitchFamily="34" charset="-120"/>
               </a:rPr>
-              <a:t>Hybrid GNN + physics-based dispersion, not a black box.</a:t>
+              <a:t>Hybrid GBR + physics-based dispersion; causal inference; actual RMSE 78.5 vs 112.9 baseline (30.5% improvement).</a:t>
             </a:r>
             <a:endParaRPr lang="en-US" sz="1050" dirty="0"/>
           </a:p>
@@ -8765,9 +9078,87 @@
                 <a:ea typeface="Calibri" pitchFamily="34" charset="-122"/>
                 <a:cs typeface="Calibri" pitchFamily="34" charset="-120"/>
               </a:rPr>
-              <a:t>Separate officer console + citizen advisory app, not one dashboard.</a:t>
+              <a:t>Separate officer console + citizen app (live Streamlit dashboard).</a:t>
             </a:r>
             <a:endParaRPr lang="en-US" sz="1050" dirty="0"/>
+          </a:p>
+        </p:txBody>
+      </p:sp>
+      <p:sp>
+        <p:nvSpPr>
+          <p:cNvPr id="16" name="Text 13"/>
+          <p:cNvSpPr/>
+          <p:nvPr/>
+        </p:nvSpPr>
+        <p:spPr>
+          <a:xfrm>
+            <a:off x="11002975" y="6419088"/>
+            <a:ext cx="822960" cy="274320"/>
+          </a:xfrm>
+          <a:prstGeom prst="rect">
+            <a:avLst/>
+          </a:prstGeom>
+          <a:noFill/>
+          <a:ln/>
+        </p:spPr>
+        <p:txBody>
+          <a:bodyPr wrap="square" lIns="0" tIns="0" rIns="0" bIns="0" rtlCol="0" anchor="ctr"/>
+          <a:lstStyle/>
+          <a:p>
+            <a:pPr marL="0" indent="0" algn="r">
+              <a:buNone/>
+            </a:pPr>
+            <a:r>
+              <a:rPr lang="en-US" sz="900" dirty="0">
+                <a:solidFill>
+                  <a:srgbClr val="5C6B73"/>
+                </a:solidFill>
+                <a:latin typeface="Calibri" pitchFamily="34" charset="0"/>
+                <a:ea typeface="Calibri" pitchFamily="34" charset="-122"/>
+                <a:cs typeface="Calibri" pitchFamily="34" charset="-120"/>
+              </a:rPr>
+              <a:t>14 / 16</a:t>
+            </a:r>
+            <a:endParaRPr lang="en-US" sz="900" dirty="0"/>
+          </a:p>
+        </p:txBody>
+      </p:sp>
+      <p:sp>
+        <p:nvSpPr>
+          <p:cNvPr id="17" name="Text 14"/>
+          <p:cNvSpPr/>
+          <p:nvPr/>
+        </p:nvSpPr>
+        <p:spPr>
+          <a:xfrm>
+            <a:off x="594360" y="6419088"/>
+            <a:ext cx="4572000" cy="274320"/>
+          </a:xfrm>
+          <a:prstGeom prst="rect">
+            <a:avLst/>
+          </a:prstGeom>
+          <a:noFill/>
+          <a:ln/>
+        </p:spPr>
+        <p:txBody>
+          <a:bodyPr wrap="square" lIns="0" tIns="0" rIns="0" bIns="0" rtlCol="0" anchor="ctr"/>
+          <a:lstStyle/>
+          <a:p>
+            <a:pPr marL="0" indent="0">
+              <a:buNone/>
+            </a:pPr>
+            <a:r>
+              <a:rPr lang="en-US" sz="900" dirty="0">
+                <a:solidFill>
+                  <a:srgbClr val="5C6B73"/>
+                </a:solidFill>
+                <a:latin typeface="Calibri" pitchFamily="34" charset="0"/>
+                <a:ea typeface="Calibri" pitchFamily="34" charset="-122"/>
+                <a:cs typeface="Calibri" pitchFamily="34" charset="-120"/>
+              </a:rPr>
+              <a:t>PRAANA — ET AI Hackathon 2026</a:t>
+            </a:r>
+            <a:endParaRPr lang="en-US" sz="900" dirty="0"/>
           </a:p>
         </p:txBody>
       </p:sp>
@@ -9539,7 +9930,7 @@
                 <a:ea typeface="Calibri" pitchFamily="34" charset="-122"/>
                 <a:cs typeface="Calibri" pitchFamily="34" charset="-120"/>
               </a:rPr>
-              <a:t>5-agent pipeline on Delhi NCR + Mumbai</a:t>
+              <a:t>Live Streamlit dashboard + GBR model with real RMSE numbers</a:t>
             </a:r>
             <a:endParaRPr lang="en-US" sz="1100" dirty="0"/>
           </a:p>
@@ -9824,6 +10215,84 @@
               <a:t>Officer console + citizen app walkthrough</a:t>
             </a:r>
             <a:endParaRPr lang="en-US" sz="1100" dirty="0"/>
+          </a:p>
+        </p:txBody>
+      </p:sp>
+      <p:sp>
+        <p:nvSpPr>
+          <p:cNvPr id="35" name="Text 26"/>
+          <p:cNvSpPr/>
+          <p:nvPr/>
+        </p:nvSpPr>
+        <p:spPr>
+          <a:xfrm>
+            <a:off x="11002975" y="6419088"/>
+            <a:ext cx="822960" cy="274320"/>
+          </a:xfrm>
+          <a:prstGeom prst="rect">
+            <a:avLst/>
+          </a:prstGeom>
+          <a:noFill/>
+          <a:ln/>
+        </p:spPr>
+        <p:txBody>
+          <a:bodyPr wrap="square" lIns="0" tIns="0" rIns="0" bIns="0" rtlCol="0" anchor="ctr"/>
+          <a:lstStyle/>
+          <a:p>
+            <a:pPr marL="0" indent="0" algn="r">
+              <a:buNone/>
+            </a:pPr>
+            <a:r>
+              <a:rPr lang="en-US" sz="900" dirty="0">
+                <a:solidFill>
+                  <a:srgbClr val="5C6B73"/>
+                </a:solidFill>
+                <a:latin typeface="Calibri" pitchFamily="34" charset="0"/>
+                <a:ea typeface="Calibri" pitchFamily="34" charset="-122"/>
+                <a:cs typeface="Calibri" pitchFamily="34" charset="-120"/>
+              </a:rPr>
+              <a:t>15 / 16</a:t>
+            </a:r>
+            <a:endParaRPr lang="en-US" sz="900" dirty="0"/>
+          </a:p>
+        </p:txBody>
+      </p:sp>
+      <p:sp>
+        <p:nvSpPr>
+          <p:cNvPr id="36" name="Text 27"/>
+          <p:cNvSpPr/>
+          <p:nvPr/>
+        </p:nvSpPr>
+        <p:spPr>
+          <a:xfrm>
+            <a:off x="594360" y="6419088"/>
+            <a:ext cx="4572000" cy="274320"/>
+          </a:xfrm>
+          <a:prstGeom prst="rect">
+            <a:avLst/>
+          </a:prstGeom>
+          <a:noFill/>
+          <a:ln/>
+        </p:spPr>
+        <p:txBody>
+          <a:bodyPr wrap="square" lIns="0" tIns="0" rIns="0" bIns="0" rtlCol="0" anchor="ctr"/>
+          <a:lstStyle/>
+          <a:p>
+            <a:pPr marL="0" indent="0">
+              <a:buNone/>
+            </a:pPr>
+            <a:r>
+              <a:rPr lang="en-US" sz="900" dirty="0">
+                <a:solidFill>
+                  <a:srgbClr val="5C6B73"/>
+                </a:solidFill>
+                <a:latin typeface="Calibri" pitchFamily="34" charset="0"/>
+                <a:ea typeface="Calibri" pitchFamily="34" charset="-122"/>
+                <a:cs typeface="Calibri" pitchFamily="34" charset="-120"/>
+              </a:rPr>
+              <a:t>PRAANA — ET AI Hackathon 2026</a:t>
+            </a:r>
+            <a:endParaRPr lang="en-US" sz="900" dirty="0"/>
           </a:p>
         </p:txBody>
       </p:sp>
@@ -10052,7 +10521,7 @@
         <p:spPr>
           <a:xfrm>
             <a:off x="594360" y="5989320"/>
-            <a:ext cx="9144000" cy="320040"/>
+            <a:ext cx="10972800" cy="320040"/>
           </a:xfrm>
           <a:prstGeom prst="rect">
             <a:avLst/>
@@ -10068,7 +10537,7 @@
               <a:buNone/>
             </a:pPr>
             <a:r>
-              <a:rPr lang="en-US" sz="1200" dirty="0">
+              <a:rPr lang="en-US" sz="1100" dirty="0">
                 <a:solidFill>
                   <a:srgbClr val="7FA8BC"/>
                 </a:solidFill>
@@ -10076,10 +10545,10 @@
                 <a:ea typeface="Calibri" pitchFamily="34" charset="-122"/>
                 <a:cs typeface="Calibri" pitchFamily="34" charset="-120"/>
               </a:rPr>
-              <a:t>Team Name: </a:t>
-            </a:r>
-            <a:r>
-              <a:rPr lang="en-US" sz="1200" dirty="0" err="1" smtClean="0">
+              <a:t>Team </a:t>
+            </a:r>
+            <a:r>
+              <a:rPr lang="en-US" sz="1100" dirty="0" err="1" smtClean="0">
                 <a:solidFill>
                   <a:srgbClr val="7FA8BC"/>
                 </a:solidFill>
@@ -10090,7 +10559,7 @@
               <a:t>Pheonix</a:t>
             </a:r>
             <a:r>
-              <a:rPr lang="en-US" sz="1200" dirty="0" smtClean="0">
+              <a:rPr lang="en-US" sz="1100" dirty="0" smtClean="0">
                 <a:solidFill>
                   <a:srgbClr val="7FA8BC"/>
                 </a:solidFill>
@@ -10100,7 +10569,18 @@
               </a:rPr>
               <a:t>      </a:t>
             </a:r>
-            <a:endParaRPr lang="en-US" sz="1200" dirty="0"/>
+            <a:r>
+              <a:rPr lang="en-US" sz="1100" dirty="0">
+                <a:solidFill>
+                  <a:srgbClr val="7FA8BC"/>
+                </a:solidFill>
+                <a:latin typeface="Calibri" pitchFamily="34" charset="0"/>
+                <a:ea typeface="Calibri" pitchFamily="34" charset="-122"/>
+                <a:cs typeface="Calibri" pitchFamily="34" charset="-120"/>
+              </a:rPr>
+              <a:t>GitHub: https://github.com/Aaditee13/praana-air-quality-intelligence.git</a:t>
+            </a:r>
+            <a:endParaRPr lang="en-US" sz="1100" dirty="0"/>
           </a:p>
         </p:txBody>
       </p:sp>
@@ -10360,7 +10840,7 @@
                 <a:ea typeface="Calibri" pitchFamily="34" charset="-122"/>
                 <a:cs typeface="Calibri" pitchFamily="34" charset="-120"/>
               </a:rPr>
-              <a:t>Estimated premature deaths/year from air pollution in India</a:t>
+              <a:t>Premature deaths/year from air pollution in India</a:t>
             </a:r>
             <a:endParaRPr lang="en-US" sz="1100" dirty="0"/>
           </a:p>
@@ -11352,6 +11832,84 @@
               <a:t>CAG Audit 2024</a:t>
             </a:r>
             <a:endParaRPr lang="en-US" sz="850" dirty="0"/>
+          </a:p>
+        </p:txBody>
+      </p:sp>
+      <p:sp>
+        <p:nvSpPr>
+          <p:cNvPr id="40" name="Text 32"/>
+          <p:cNvSpPr/>
+          <p:nvPr/>
+        </p:nvSpPr>
+        <p:spPr>
+          <a:xfrm>
+            <a:off x="11002975" y="6419088"/>
+            <a:ext cx="822960" cy="274320"/>
+          </a:xfrm>
+          <a:prstGeom prst="rect">
+            <a:avLst/>
+          </a:prstGeom>
+          <a:noFill/>
+          <a:ln/>
+        </p:spPr>
+        <p:txBody>
+          <a:bodyPr wrap="square" lIns="0" tIns="0" rIns="0" bIns="0" rtlCol="0" anchor="ctr"/>
+          <a:lstStyle/>
+          <a:p>
+            <a:pPr marL="0" indent="0" algn="r">
+              <a:buNone/>
+            </a:pPr>
+            <a:r>
+              <a:rPr lang="en-US" sz="900" dirty="0">
+                <a:solidFill>
+                  <a:srgbClr val="5C6B73"/>
+                </a:solidFill>
+                <a:latin typeface="Calibri" pitchFamily="34" charset="0"/>
+                <a:ea typeface="Calibri" pitchFamily="34" charset="-122"/>
+                <a:cs typeface="Calibri" pitchFamily="34" charset="-120"/>
+              </a:rPr>
+              <a:t>02 / 16</a:t>
+            </a:r>
+            <a:endParaRPr lang="en-US" sz="900" dirty="0"/>
+          </a:p>
+        </p:txBody>
+      </p:sp>
+      <p:sp>
+        <p:nvSpPr>
+          <p:cNvPr id="41" name="Text 33"/>
+          <p:cNvSpPr/>
+          <p:nvPr/>
+        </p:nvSpPr>
+        <p:spPr>
+          <a:xfrm>
+            <a:off x="594360" y="6419088"/>
+            <a:ext cx="4572000" cy="274320"/>
+          </a:xfrm>
+          <a:prstGeom prst="rect">
+            <a:avLst/>
+          </a:prstGeom>
+          <a:noFill/>
+          <a:ln/>
+        </p:spPr>
+        <p:txBody>
+          <a:bodyPr wrap="square" lIns="0" tIns="0" rIns="0" bIns="0" rtlCol="0" anchor="ctr"/>
+          <a:lstStyle/>
+          <a:p>
+            <a:pPr marL="0" indent="0">
+              <a:buNone/>
+            </a:pPr>
+            <a:r>
+              <a:rPr lang="en-US" sz="900" dirty="0">
+                <a:solidFill>
+                  <a:srgbClr val="5C6B73"/>
+                </a:solidFill>
+                <a:latin typeface="Calibri" pitchFamily="34" charset="0"/>
+                <a:ea typeface="Calibri" pitchFamily="34" charset="-122"/>
+                <a:cs typeface="Calibri" pitchFamily="34" charset="-120"/>
+              </a:rPr>
+              <a:t>PRAANA — ET AI Hackathon 2026</a:t>
+            </a:r>
+            <a:endParaRPr lang="en-US" sz="900" dirty="0"/>
           </a:p>
         </p:txBody>
       </p:sp>
@@ -11513,12 +12071,12 @@
         </p:nvSpPr>
         <p:spPr>
           <a:xfrm>
-            <a:off x="594360" y="1965960"/>
-            <a:ext cx="3520440" cy="1554480"/>
+            <a:off x="594360" y="1874520"/>
+            <a:ext cx="3520440" cy="1463040"/>
           </a:xfrm>
           <a:prstGeom prst="roundRect">
             <a:avLst>
-              <a:gd name="adj" fmla="val 5294"/>
+              <a:gd name="adj" fmla="val 5625"/>
             </a:avLst>
           </a:prstGeom>
           <a:solidFill>
@@ -11542,8 +12100,8 @@
         </p:nvSpPr>
         <p:spPr>
           <a:xfrm>
-            <a:off x="822960" y="2194560"/>
-            <a:ext cx="502920" cy="502920"/>
+            <a:off x="822960" y="2084832"/>
+            <a:ext cx="457200" cy="457200"/>
           </a:xfrm>
           <a:prstGeom prst="ellipse">
             <a:avLst/>
@@ -11570,8 +12128,8 @@
         </p:blipFill>
         <p:spPr>
           <a:xfrm>
-            <a:off x="898398" y="2269998"/>
-            <a:ext cx="352044" cy="352044"/>
+            <a:off x="891540" y="2153412"/>
+            <a:ext cx="320040" cy="320040"/>
           </a:xfrm>
           <a:prstGeom prst="rect">
             <a:avLst/>
@@ -11586,8 +12144,8 @@
         </p:nvSpPr>
         <p:spPr>
           <a:xfrm>
-            <a:off x="1463040" y="2121408"/>
-            <a:ext cx="2468880" cy="411480"/>
+            <a:off x="1417320" y="2029968"/>
+            <a:ext cx="2468880" cy="384048"/>
           </a:xfrm>
           <a:prstGeom prst="rect">
             <a:avLst/>
@@ -11603,7 +12161,7 @@
               <a:buNone/>
             </a:pPr>
             <a:r>
-              <a:rPr lang="en-US" sz="1900" b="1" dirty="0">
+              <a:rPr lang="en-US" sz="1800" b="1" dirty="0">
                 <a:solidFill>
                   <a:srgbClr val="1B3B5F"/>
                 </a:solidFill>
@@ -11613,7 +12171,7 @@
               </a:rPr>
               <a:t>Who</a:t>
             </a:r>
-            <a:endParaRPr lang="en-US" sz="1900" dirty="0"/>
+            <a:endParaRPr lang="en-US" sz="1800" dirty="0"/>
           </a:p>
         </p:txBody>
       </p:sp>
@@ -11625,8 +12183,8 @@
         </p:nvSpPr>
         <p:spPr>
           <a:xfrm>
-            <a:off x="822960" y="2697480"/>
-            <a:ext cx="3063240" cy="685800"/>
+            <a:off x="822960" y="2560320"/>
+            <a:ext cx="3108960" cy="685800"/>
           </a:xfrm>
           <a:prstGeom prst="rect">
             <a:avLst/>
@@ -11642,7 +12200,7 @@
               <a:buNone/>
             </a:pPr>
             <a:r>
-              <a:rPr lang="en-US" sz="1150" dirty="0">
+              <a:rPr lang="en-US" sz="1100" dirty="0">
                 <a:solidFill>
                   <a:srgbClr val="1F2A33"/>
                 </a:solidFill>
@@ -11652,7 +12210,7 @@
               </a:rPr>
               <a:t>is causing this pollution right now?</a:t>
             </a:r>
-            <a:endParaRPr lang="en-US" sz="1150" dirty="0"/>
+            <a:endParaRPr lang="en-US" sz="1100" dirty="0"/>
           </a:p>
         </p:txBody>
       </p:sp>
@@ -11664,12 +12222,12 @@
         </p:nvSpPr>
         <p:spPr>
           <a:xfrm>
-            <a:off x="4297680" y="1965960"/>
-            <a:ext cx="3520440" cy="1554480"/>
+            <a:off x="4315968" y="1874520"/>
+            <a:ext cx="3520440" cy="1463040"/>
           </a:xfrm>
           <a:prstGeom prst="roundRect">
             <a:avLst>
-              <a:gd name="adj" fmla="val 5294"/>
+              <a:gd name="adj" fmla="val 5625"/>
             </a:avLst>
           </a:prstGeom>
           <a:solidFill>
@@ -11693,8 +12251,8 @@
         </p:nvSpPr>
         <p:spPr>
           <a:xfrm>
-            <a:off x="4526280" y="2194560"/>
-            <a:ext cx="502920" cy="502920"/>
+            <a:off x="4544568" y="2084832"/>
+            <a:ext cx="457200" cy="457200"/>
           </a:xfrm>
           <a:prstGeom prst="ellipse">
             <a:avLst/>
@@ -11721,8 +12279,8 @@
         </p:blipFill>
         <p:spPr>
           <a:xfrm>
-            <a:off x="4601718" y="2269998"/>
-            <a:ext cx="352044" cy="352044"/>
+            <a:off x="4613148" y="2153412"/>
+            <a:ext cx="320040" cy="320040"/>
           </a:xfrm>
           <a:prstGeom prst="rect">
             <a:avLst/>
@@ -11737,8 +12295,8 @@
         </p:nvSpPr>
         <p:spPr>
           <a:xfrm>
-            <a:off x="5166360" y="2121408"/>
-            <a:ext cx="2468880" cy="411480"/>
+            <a:off x="5138928" y="2029968"/>
+            <a:ext cx="2468880" cy="384048"/>
           </a:xfrm>
           <a:prstGeom prst="rect">
             <a:avLst/>
@@ -11754,7 +12312,7 @@
               <a:buNone/>
             </a:pPr>
             <a:r>
-              <a:rPr lang="en-US" sz="1900" b="1" dirty="0">
+              <a:rPr lang="en-US" sz="1800" b="1" dirty="0">
                 <a:solidFill>
                   <a:srgbClr val="1B3B5F"/>
                 </a:solidFill>
@@ -11764,7 +12322,7 @@
               </a:rPr>
               <a:t>How bad</a:t>
             </a:r>
-            <a:endParaRPr lang="en-US" sz="1900" dirty="0"/>
+            <a:endParaRPr lang="en-US" sz="1800" dirty="0"/>
           </a:p>
         </p:txBody>
       </p:sp>
@@ -11776,8 +12334,8 @@
         </p:nvSpPr>
         <p:spPr>
           <a:xfrm>
-            <a:off x="4526280" y="2697480"/>
-            <a:ext cx="3063240" cy="685800"/>
+            <a:off x="4544568" y="2560320"/>
+            <a:ext cx="3108960" cy="685800"/>
           </a:xfrm>
           <a:prstGeom prst="rect">
             <a:avLst/>
@@ -11793,7 +12351,7 @@
               <a:buNone/>
             </a:pPr>
             <a:r>
-              <a:rPr lang="en-US" sz="1150" dirty="0">
+              <a:rPr lang="en-US" sz="1100" dirty="0">
                 <a:solidFill>
                   <a:srgbClr val="1F2A33"/>
                 </a:solidFill>
@@ -11803,7 +12361,7 @@
               </a:rPr>
               <a:t>will it get over the next 72 hours?</a:t>
             </a:r>
-            <a:endParaRPr lang="en-US" sz="1150" dirty="0"/>
+            <a:endParaRPr lang="en-US" sz="1100" dirty="0"/>
           </a:p>
         </p:txBody>
       </p:sp>
@@ -11815,12 +12373,12 @@
         </p:nvSpPr>
         <p:spPr>
           <a:xfrm>
-            <a:off x="8001000" y="1965960"/>
-            <a:ext cx="3520440" cy="1554480"/>
+            <a:off x="8037576" y="1874520"/>
+            <a:ext cx="3520440" cy="1463040"/>
           </a:xfrm>
           <a:prstGeom prst="roundRect">
             <a:avLst>
-              <a:gd name="adj" fmla="val 5294"/>
+              <a:gd name="adj" fmla="val 5625"/>
             </a:avLst>
           </a:prstGeom>
           <a:solidFill>
@@ -11844,8 +12402,8 @@
         </p:nvSpPr>
         <p:spPr>
           <a:xfrm>
-            <a:off x="8229600" y="2194560"/>
-            <a:ext cx="502920" cy="502920"/>
+            <a:off x="8266176" y="2084832"/>
+            <a:ext cx="457200" cy="457200"/>
           </a:xfrm>
           <a:prstGeom prst="ellipse">
             <a:avLst/>
@@ -11872,8 +12430,8 @@
         </p:blipFill>
         <p:spPr>
           <a:xfrm>
-            <a:off x="8305038" y="2269998"/>
-            <a:ext cx="352044" cy="352044"/>
+            <a:off x="8334756" y="2153412"/>
+            <a:ext cx="320040" cy="320040"/>
           </a:xfrm>
           <a:prstGeom prst="rect">
             <a:avLst/>
@@ -11888,8 +12446,8 @@
         </p:nvSpPr>
         <p:spPr>
           <a:xfrm>
-            <a:off x="8869680" y="2121408"/>
-            <a:ext cx="2468880" cy="411480"/>
+            <a:off x="8860536" y="2029968"/>
+            <a:ext cx="2468880" cy="384048"/>
           </a:xfrm>
           <a:prstGeom prst="rect">
             <a:avLst/>
@@ -11905,7 +12463,7 @@
               <a:buNone/>
             </a:pPr>
             <a:r>
-              <a:rPr lang="en-US" sz="1900" b="1" dirty="0">
+              <a:rPr lang="en-US" sz="1800" b="1" dirty="0">
                 <a:solidFill>
                   <a:srgbClr val="1B3B5F"/>
                 </a:solidFill>
@@ -11915,7 +12473,7 @@
               </a:rPr>
               <a:t>Where</a:t>
             </a:r>
-            <a:endParaRPr lang="en-US" sz="1900" dirty="0"/>
+            <a:endParaRPr lang="en-US" sz="1800" dirty="0"/>
           </a:p>
         </p:txBody>
       </p:sp>
@@ -11927,8 +12485,8 @@
         </p:nvSpPr>
         <p:spPr>
           <a:xfrm>
-            <a:off x="8229600" y="2697480"/>
-            <a:ext cx="3063240" cy="685800"/>
+            <a:off x="8266176" y="2560320"/>
+            <a:ext cx="3108960" cy="685800"/>
           </a:xfrm>
           <a:prstGeom prst="rect">
             <a:avLst/>
@@ -11944,7 +12502,7 @@
               <a:buNone/>
             </a:pPr>
             <a:r>
-              <a:rPr lang="en-US" sz="1150" dirty="0">
+              <a:rPr lang="en-US" sz="1100" dirty="0">
                 <a:solidFill>
                   <a:srgbClr val="1F2A33"/>
                 </a:solidFill>
@@ -11954,7 +12512,7 @@
               </a:rPr>
               <a:t>should enforcement be sent today?</a:t>
             </a:r>
-            <a:endParaRPr lang="en-US" sz="1150" dirty="0"/>
+            <a:endParaRPr lang="en-US" sz="1100" dirty="0"/>
           </a:p>
         </p:txBody>
       </p:sp>
@@ -11966,7 +12524,7 @@
         </p:nvSpPr>
         <p:spPr>
           <a:xfrm>
-            <a:off x="594360" y="3794760"/>
+            <a:off x="594360" y="3547872"/>
             <a:ext cx="10515600" cy="365760"/>
           </a:xfrm>
           <a:prstGeom prst="rect">
@@ -11983,7 +12541,7 @@
               <a:buNone/>
             </a:pPr>
             <a:r>
-              <a:rPr lang="en-US" sz="1300" b="1" dirty="0">
+              <a:rPr lang="en-US" sz="1250" b="1" dirty="0">
                 <a:solidFill>
                   <a:srgbClr val="E8862E"/>
                 </a:solidFill>
@@ -11991,9 +12549,9 @@
                 <a:ea typeface="Calibri" pitchFamily="34" charset="-122"/>
                 <a:cs typeface="Calibri" pitchFamily="34" charset="-120"/>
               </a:rPr>
-              <a:t>Nobody answers all three today.</a:t>
-            </a:r>
-            <a:endParaRPr lang="en-US" sz="1300" dirty="0"/>
+              <a:t>Nobody answers all three together. IITM-DSS and SAFAR come closest — but stop at diagnosis.</a:t>
+            </a:r>
+            <a:endParaRPr lang="en-US" sz="1250" dirty="0"/>
           </a:p>
         </p:txBody>
       </p:sp>
@@ -12005,12 +12563,12 @@
         </p:nvSpPr>
         <p:spPr>
           <a:xfrm>
-            <a:off x="594360" y="4343400"/>
-            <a:ext cx="5212080" cy="1965960"/>
+            <a:off x="594360" y="4005072"/>
+            <a:ext cx="5212080" cy="2304288"/>
           </a:xfrm>
           <a:prstGeom prst="roundRect">
             <a:avLst>
-              <a:gd name="adj" fmla="val 4186"/>
+              <a:gd name="adj" fmla="val 3571"/>
             </a:avLst>
           </a:prstGeom>
           <a:solidFill>
@@ -12034,8 +12592,8 @@
         </p:nvSpPr>
         <p:spPr>
           <a:xfrm>
-            <a:off x="822960" y="4498848"/>
-            <a:ext cx="4572000" cy="274320"/>
+            <a:off x="822960" y="4151376"/>
+            <a:ext cx="4572000" cy="256032"/>
           </a:xfrm>
           <a:prstGeom prst="rect">
             <a:avLst/>
@@ -12051,7 +12609,7 @@
               <a:buNone/>
             </a:pPr>
             <a:r>
-              <a:rPr lang="en-US" sz="1100" b="1" kern="0" spc="150" dirty="0">
+              <a:rPr lang="en-US" sz="1000" b="1" kern="0" spc="150" dirty="0">
                 <a:solidFill>
                   <a:srgbClr val="5C6B73"/>
                 </a:solidFill>
@@ -12061,7 +12619,7 @@
               </a:rPr>
               <a:t>WHAT EXISTS TODAY</a:t>
             </a:r>
-            <a:endParaRPr lang="en-US" sz="1100" dirty="0"/>
+            <a:endParaRPr lang="en-US" sz="1000" dirty="0"/>
           </a:p>
         </p:txBody>
       </p:sp>
@@ -12073,8 +12631,8 @@
         </p:nvSpPr>
         <p:spPr>
           <a:xfrm>
-            <a:off x="822960" y="4828032"/>
-            <a:ext cx="4846320" cy="384048"/>
+            <a:off x="822960" y="4462272"/>
+            <a:ext cx="4846320" cy="402336"/>
           </a:xfrm>
           <a:prstGeom prst="rect">
             <a:avLst/>
@@ -12090,7 +12648,7 @@
               <a:buNone/>
             </a:pPr>
             <a:r>
-              <a:rPr lang="en-US" sz="1150" b="1" dirty="0">
+              <a:rPr lang="en-US" sz="1100" b="1" dirty="0">
                 <a:solidFill>
                   <a:srgbClr val="1B3B5F"/>
                 </a:solidFill>
@@ -12098,10 +12656,10 @@
                 <a:ea typeface="Calibri" pitchFamily="34" charset="-122"/>
                 <a:cs typeface="Calibri" pitchFamily="34" charset="-120"/>
               </a:rPr>
-              <a:t>CPCB Dashboard: </a:t>
-            </a:r>
-            <a:r>
-              <a:rPr lang="en-US" sz="1150" dirty="0">
+              <a:t>IITM-DSS: </a:t>
+            </a:r>
+            <a:r>
+              <a:rPr lang="en-US" sz="1100" dirty="0">
                 <a:solidFill>
                   <a:srgbClr val="1F2A33"/>
                 </a:solidFill>
@@ -12109,9 +12667,9 @@
                 <a:ea typeface="Calibri" pitchFamily="34" charset="-122"/>
                 <a:cs typeface="Calibri" pitchFamily="34" charset="-120"/>
               </a:rPr>
-              <a:t>Shows the current AQI reading</a:t>
-            </a:r>
-            <a:endParaRPr lang="en-US" sz="1150" dirty="0"/>
+              <a:t>City-level source apportionment (29 sources), Delhi NCR</a:t>
+            </a:r>
+            <a:endParaRPr lang="en-US" sz="1100" dirty="0"/>
           </a:p>
         </p:txBody>
       </p:sp>
@@ -12123,8 +12681,8 @@
         </p:nvSpPr>
         <p:spPr>
           <a:xfrm>
-            <a:off x="822960" y="5248656"/>
-            <a:ext cx="4846320" cy="384048"/>
+            <a:off x="822960" y="4901184"/>
+            <a:ext cx="4846320" cy="402336"/>
           </a:xfrm>
           <a:prstGeom prst="rect">
             <a:avLst/>
@@ -12140,7 +12698,7 @@
               <a:buNone/>
             </a:pPr>
             <a:r>
-              <a:rPr lang="en-US" sz="1150" b="1" dirty="0">
+              <a:rPr lang="en-US" sz="1100" b="1" dirty="0">
                 <a:solidFill>
                   <a:srgbClr val="1B3B5F"/>
                 </a:solidFill>
@@ -12148,10 +12706,10 @@
                 <a:ea typeface="Calibri" pitchFamily="34" charset="-122"/>
                 <a:cs typeface="Calibri" pitchFamily="34" charset="-120"/>
               </a:rPr>
-              <a:t>IQAir / AQI India apps: </a:t>
-            </a:r>
-            <a:r>
-              <a:rPr lang="en-US" sz="1150" dirty="0">
+              <a:t>SAFAR: </a:t>
+            </a:r>
+            <a:r>
+              <a:rPr lang="en-US" sz="1100" dirty="0">
                 <a:solidFill>
                   <a:srgbClr val="1F2A33"/>
                 </a:solidFill>
@@ -12159,9 +12717,9 @@
                 <a:ea typeface="Calibri" pitchFamily="34" charset="-122"/>
                 <a:cs typeface="Calibri" pitchFamily="34" charset="-120"/>
               </a:rPr>
-              <a:t>City-level AQI number</a:t>
-            </a:r>
-            <a:endParaRPr lang="en-US" sz="1150" dirty="0"/>
+              <a:t>3–10 day city-level AQI forecasts for 7 cities</a:t>
+            </a:r>
+            <a:endParaRPr lang="en-US" sz="1100" dirty="0"/>
           </a:p>
         </p:txBody>
       </p:sp>
@@ -12173,8 +12731,8 @@
         </p:nvSpPr>
         <p:spPr>
           <a:xfrm>
-            <a:off x="822960" y="5669280"/>
-            <a:ext cx="4846320" cy="384048"/>
+            <a:off x="822960" y="5340096"/>
+            <a:ext cx="4846320" cy="402336"/>
           </a:xfrm>
           <a:prstGeom prst="rect">
             <a:avLst/>
@@ -12190,7 +12748,7 @@
               <a:buNone/>
             </a:pPr>
             <a:r>
-              <a:rPr lang="en-US" sz="1150" b="1" dirty="0">
+              <a:rPr lang="en-US" sz="1100" b="1" dirty="0">
                 <a:solidFill>
                   <a:srgbClr val="1B3B5F"/>
                 </a:solidFill>
@@ -12198,10 +12756,10 @@
                 <a:ea typeface="Calibri" pitchFamily="34" charset="-122"/>
                 <a:cs typeface="Calibri" pitchFamily="34" charset="-120"/>
               </a:rPr>
-              <a:t>Academic studies: </a:t>
-            </a:r>
-            <a:r>
-              <a:rPr lang="en-US" sz="1150" dirty="0">
+              <a:t>CPCB Dashboard: </a:t>
+            </a:r>
+            <a:r>
+              <a:rPr lang="en-US" sz="1100" dirty="0">
                 <a:solidFill>
                   <a:srgbClr val="1F2A33"/>
                 </a:solidFill>
@@ -12209,26 +12767,76 @@
                 <a:ea typeface="Calibri" pitchFamily="34" charset="-122"/>
                 <a:cs typeface="Calibri" pitchFamily="34" charset="-120"/>
               </a:rPr>
-              <a:t>Offline, periodic source apportionment</a:t>
-            </a:r>
-            <a:endParaRPr lang="en-US" sz="1150" dirty="0"/>
-          </a:p>
-        </p:txBody>
-      </p:sp>
-      <p:sp>
-        <p:nvSpPr>
-          <p:cNvPr id="26" name="Shape 21"/>
-          <p:cNvSpPr/>
-          <p:nvPr/>
-        </p:nvSpPr>
-        <p:spPr>
-          <a:xfrm>
-            <a:off x="6035040" y="4343400"/>
-            <a:ext cx="5212080" cy="1965960"/>
+              <a:t>Shows the current AQI reading</a:t>
+            </a:r>
+            <a:endParaRPr lang="en-US" sz="1100" dirty="0"/>
+          </a:p>
+        </p:txBody>
+      </p:sp>
+      <p:sp>
+        <p:nvSpPr>
+          <p:cNvPr id="26" name="Text 21"/>
+          <p:cNvSpPr/>
+          <p:nvPr/>
+        </p:nvSpPr>
+        <p:spPr>
+          <a:xfrm>
+            <a:off x="822960" y="5779008"/>
+            <a:ext cx="4846320" cy="402336"/>
+          </a:xfrm>
+          <a:prstGeom prst="rect">
+            <a:avLst/>
+          </a:prstGeom>
+          <a:noFill/>
+          <a:ln/>
+        </p:spPr>
+        <p:txBody>
+          <a:bodyPr wrap="square" lIns="0" tIns="0" rIns="0" bIns="0" rtlCol="0" anchor="ctr"/>
+          <a:lstStyle/>
+          <a:p>
+            <a:pPr marL="0" indent="0">
+              <a:buNone/>
+            </a:pPr>
+            <a:r>
+              <a:rPr lang="en-US" sz="1100" b="1" dirty="0">
+                <a:solidFill>
+                  <a:srgbClr val="1B3B5F"/>
+                </a:solidFill>
+                <a:latin typeface="Calibri" pitchFamily="34" charset="0"/>
+                <a:ea typeface="Calibri" pitchFamily="34" charset="-122"/>
+                <a:cs typeface="Calibri" pitchFamily="34" charset="-120"/>
+              </a:rPr>
+              <a:t>IQAir / apps: </a:t>
+            </a:r>
+            <a:r>
+              <a:rPr lang="en-US" sz="1100" dirty="0">
+                <a:solidFill>
+                  <a:srgbClr val="1F2A33"/>
+                </a:solidFill>
+                <a:latin typeface="Calibri" pitchFamily="34" charset="0"/>
+                <a:ea typeface="Calibri" pitchFamily="34" charset="-122"/>
+                <a:cs typeface="Calibri" pitchFamily="34" charset="-120"/>
+              </a:rPr>
+              <a:t>City-level AQI number</a:t>
+            </a:r>
+            <a:endParaRPr lang="en-US" sz="1100" dirty="0"/>
+          </a:p>
+        </p:txBody>
+      </p:sp>
+      <p:sp>
+        <p:nvSpPr>
+          <p:cNvPr id="27" name="Shape 22"/>
+          <p:cNvSpPr/>
+          <p:nvPr/>
+        </p:nvSpPr>
+        <p:spPr>
+          <a:xfrm>
+            <a:off x="6035040" y="4005072"/>
+            <a:ext cx="5212080" cy="2304288"/>
           </a:xfrm>
           <a:prstGeom prst="roundRect">
             <a:avLst>
-              <a:gd name="adj" fmla="val 4186"/>
+              <a:gd name="adj" fmla="val 3571"/>
             </a:avLst>
           </a:prstGeom>
           <a:solidFill>
@@ -12246,14 +12854,14 @@
       </p:sp>
       <p:sp>
         <p:nvSpPr>
-          <p:cNvPr id="27" name="Text 22"/>
-          <p:cNvSpPr/>
-          <p:nvPr/>
-        </p:nvSpPr>
-        <p:spPr>
-          <a:xfrm>
-            <a:off x="6263640" y="4498848"/>
-            <a:ext cx="4572000" cy="274320"/>
+          <p:cNvPr id="28" name="Text 23"/>
+          <p:cNvSpPr/>
+          <p:nvPr/>
+        </p:nvSpPr>
+        <p:spPr>
+          <a:xfrm>
+            <a:off x="6263640" y="4151376"/>
+            <a:ext cx="4572000" cy="256032"/>
           </a:xfrm>
           <a:prstGeom prst="rect">
             <a:avLst/>
@@ -12269,7 +12877,7 @@
               <a:buNone/>
             </a:pPr>
             <a:r>
-              <a:rPr lang="en-US" sz="1100" b="1" kern="0" spc="150" dirty="0">
+              <a:rPr lang="en-US" sz="1000" b="1" kern="0" spc="150" dirty="0">
                 <a:solidFill>
                   <a:srgbClr val="DCEAF2"/>
                 </a:solidFill>
@@ -12277,22 +12885,22 @@
                 <a:ea typeface="Calibri" pitchFamily="34" charset="-122"/>
                 <a:cs typeface="Calibri" pitchFamily="34" charset="-120"/>
               </a:rPr>
-              <a:t>WHAT PRAANA DOES</a:t>
-            </a:r>
-            <a:endParaRPr lang="en-US" sz="1100" dirty="0"/>
-          </a:p>
-        </p:txBody>
-      </p:sp>
-      <p:sp>
-        <p:nvSpPr>
-          <p:cNvPr id="28" name="Text 23"/>
-          <p:cNvSpPr/>
-          <p:nvPr/>
-        </p:nvSpPr>
-        <p:spPr>
-          <a:xfrm>
-            <a:off x="6263640" y="4828032"/>
-            <a:ext cx="4846320" cy="384048"/>
+              <a:t>WHAT PRAANA ADDS ON TOP</a:t>
+            </a:r>
+            <a:endParaRPr lang="en-US" sz="1000" dirty="0"/>
+          </a:p>
+        </p:txBody>
+      </p:sp>
+      <p:sp>
+        <p:nvSpPr>
+          <p:cNvPr id="29" name="Text 24"/>
+          <p:cNvSpPr/>
+          <p:nvPr/>
+        </p:nvSpPr>
+        <p:spPr>
+          <a:xfrm>
+            <a:off x="6263640" y="4462272"/>
+            <a:ext cx="4846320" cy="402336"/>
           </a:xfrm>
           <a:prstGeom prst="rect">
             <a:avLst/>
@@ -12308,7 +12916,7 @@
               <a:buNone/>
             </a:pPr>
             <a:r>
-              <a:rPr lang="en-US" sz="1150" dirty="0">
+              <a:rPr lang="en-US" sz="1100" dirty="0">
                 <a:solidFill>
                   <a:srgbClr val="FFFFFF"/>
                 </a:solidFill>
@@ -12316,22 +12924,22 @@
                 <a:ea typeface="Calibri" pitchFamily="34" charset="-122"/>
                 <a:cs typeface="Calibri" pitchFamily="34" charset="-120"/>
               </a:rPr>
-              <a:t>Attributes pollution to its source, hourly, ward by ward</a:t>
-            </a:r>
-            <a:endParaRPr lang="en-US" sz="1150" dirty="0"/>
-          </a:p>
-        </p:txBody>
-      </p:sp>
-      <p:sp>
-        <p:nvSpPr>
-          <p:cNvPr id="29" name="Text 24"/>
-          <p:cNvSpPr/>
-          <p:nvPr/>
-        </p:nvSpPr>
-        <p:spPr>
-          <a:xfrm>
-            <a:off x="6263640" y="5248656"/>
-            <a:ext cx="4846320" cy="384048"/>
+              <a:t>1km ward-level granularity (not just city-level)</a:t>
+            </a:r>
+            <a:endParaRPr lang="en-US" sz="1100" dirty="0"/>
+          </a:p>
+        </p:txBody>
+      </p:sp>
+      <p:sp>
+        <p:nvSpPr>
+          <p:cNvPr id="30" name="Text 25"/>
+          <p:cNvSpPr/>
+          <p:nvPr/>
+        </p:nvSpPr>
+        <p:spPr>
+          <a:xfrm>
+            <a:off x="6263640" y="4901184"/>
+            <a:ext cx="4846320" cy="402336"/>
           </a:xfrm>
           <a:prstGeom prst="rect">
             <a:avLst/>
@@ -12347,7 +12955,7 @@
               <a:buNone/>
             </a:pPr>
             <a:r>
-              <a:rPr lang="en-US" sz="1150" dirty="0">
+              <a:rPr lang="en-US" sz="1100" dirty="0">
                 <a:solidFill>
                   <a:srgbClr val="FFFFFF"/>
                 </a:solidFill>
@@ -12355,22 +12963,22 @@
                 <a:ea typeface="Calibri" pitchFamily="34" charset="-122"/>
                 <a:cs typeface="Calibri" pitchFamily="34" charset="-120"/>
               </a:rPr>
-              <a:t>Forecasts AQI 24–72hrs ahead at 1km resolution</a:t>
-            </a:r>
-            <a:endParaRPr lang="en-US" sz="1150" dirty="0"/>
-          </a:p>
-        </p:txBody>
-      </p:sp>
-      <p:sp>
-        <p:nvSpPr>
-          <p:cNvPr id="30" name="Text 25"/>
-          <p:cNvSpPr/>
-          <p:nvPr/>
-        </p:nvSpPr>
-        <p:spPr>
-          <a:xfrm>
-            <a:off x="6263640" y="5669280"/>
-            <a:ext cx="4846320" cy="384048"/>
+              <a:t>Ranked enforcement actions — which site to inspect today</a:t>
+            </a:r>
+            <a:endParaRPr lang="en-US" sz="1100" dirty="0"/>
+          </a:p>
+        </p:txBody>
+      </p:sp>
+      <p:sp>
+        <p:nvSpPr>
+          <p:cNvPr id="31" name="Text 26"/>
+          <p:cNvSpPr/>
+          <p:nvPr/>
+        </p:nvSpPr>
+        <p:spPr>
+          <a:xfrm>
+            <a:off x="6263640" y="5340096"/>
+            <a:ext cx="4846320" cy="402336"/>
           </a:xfrm>
           <a:prstGeom prst="rect">
             <a:avLst/>
@@ -12386,7 +12994,7 @@
               <a:buNone/>
             </a:pPr>
             <a:r>
-              <a:rPr lang="en-US" sz="1150" dirty="0">
+              <a:rPr lang="en-US" sz="1100" dirty="0">
                 <a:solidFill>
                   <a:srgbClr val="FFFFFF"/>
                 </a:solidFill>
@@ -12394,9 +13002,126 @@
                 <a:ea typeface="Calibri" pitchFamily="34" charset="-122"/>
                 <a:cs typeface="Calibri" pitchFamily="34" charset="-120"/>
               </a:rPr>
-              <a:t>Ranks enforcement actions by expected AQI impact</a:t>
-            </a:r>
-            <a:endParaRPr lang="en-US" sz="1150" dirty="0"/>
+              <a:t>Cross-city learning loop — tracks what interventions worked</a:t>
+            </a:r>
+            <a:endParaRPr lang="en-US" sz="1100" dirty="0"/>
+          </a:p>
+        </p:txBody>
+      </p:sp>
+      <p:sp>
+        <p:nvSpPr>
+          <p:cNvPr id="32" name="Text 27"/>
+          <p:cNvSpPr/>
+          <p:nvPr/>
+        </p:nvSpPr>
+        <p:spPr>
+          <a:xfrm>
+            <a:off x="6263640" y="5779008"/>
+            <a:ext cx="4846320" cy="402336"/>
+          </a:xfrm>
+          <a:prstGeom prst="rect">
+            <a:avLst/>
+          </a:prstGeom>
+          <a:noFill/>
+          <a:ln/>
+        </p:spPr>
+        <p:txBody>
+          <a:bodyPr wrap="square" lIns="0" tIns="0" rIns="0" bIns="0" rtlCol="0" anchor="ctr"/>
+          <a:lstStyle/>
+          <a:p>
+            <a:pPr marL="0" indent="0">
+              <a:buNone/>
+            </a:pPr>
+            <a:r>
+              <a:rPr lang="en-US" sz="1100" dirty="0">
+                <a:solidFill>
+                  <a:srgbClr val="FFFFFF"/>
+                </a:solidFill>
+                <a:latin typeface="Calibri" pitchFamily="34" charset="0"/>
+                <a:ea typeface="Calibri" pitchFamily="34" charset="-122"/>
+                <a:cs typeface="Calibri" pitchFamily="34" charset="-120"/>
+              </a:rPr>
+              <a:t>Regional-language citizen advisories</a:t>
+            </a:r>
+            <a:endParaRPr lang="en-US" sz="1100" dirty="0"/>
+          </a:p>
+        </p:txBody>
+      </p:sp>
+      <p:sp>
+        <p:nvSpPr>
+          <p:cNvPr id="33" name="Text 28"/>
+          <p:cNvSpPr/>
+          <p:nvPr/>
+        </p:nvSpPr>
+        <p:spPr>
+          <a:xfrm>
+            <a:off x="11002975" y="6419088"/>
+            <a:ext cx="822960" cy="274320"/>
+          </a:xfrm>
+          <a:prstGeom prst="rect">
+            <a:avLst/>
+          </a:prstGeom>
+          <a:noFill/>
+          <a:ln/>
+        </p:spPr>
+        <p:txBody>
+          <a:bodyPr wrap="square" lIns="0" tIns="0" rIns="0" bIns="0" rtlCol="0" anchor="ctr"/>
+          <a:lstStyle/>
+          <a:p>
+            <a:pPr marL="0" indent="0" algn="r">
+              <a:buNone/>
+            </a:pPr>
+            <a:r>
+              <a:rPr lang="en-US" sz="900" dirty="0">
+                <a:solidFill>
+                  <a:srgbClr val="5C6B73"/>
+                </a:solidFill>
+                <a:latin typeface="Calibri" pitchFamily="34" charset="0"/>
+                <a:ea typeface="Calibri" pitchFamily="34" charset="-122"/>
+                <a:cs typeface="Calibri" pitchFamily="34" charset="-120"/>
+              </a:rPr>
+              <a:t>03 / 16</a:t>
+            </a:r>
+            <a:endParaRPr lang="en-US" sz="900" dirty="0"/>
+          </a:p>
+        </p:txBody>
+      </p:sp>
+      <p:sp>
+        <p:nvSpPr>
+          <p:cNvPr id="34" name="Text 29"/>
+          <p:cNvSpPr/>
+          <p:nvPr/>
+        </p:nvSpPr>
+        <p:spPr>
+          <a:xfrm>
+            <a:off x="594360" y="6419088"/>
+            <a:ext cx="4572000" cy="274320"/>
+          </a:xfrm>
+          <a:prstGeom prst="rect">
+            <a:avLst/>
+          </a:prstGeom>
+          <a:noFill/>
+          <a:ln/>
+        </p:spPr>
+        <p:txBody>
+          <a:bodyPr wrap="square" lIns="0" tIns="0" rIns="0" bIns="0" rtlCol="0" anchor="ctr"/>
+          <a:lstStyle/>
+          <a:p>
+            <a:pPr marL="0" indent="0">
+              <a:buNone/>
+            </a:pPr>
+            <a:r>
+              <a:rPr lang="en-US" sz="900" dirty="0">
+                <a:solidFill>
+                  <a:srgbClr val="5C6B73"/>
+                </a:solidFill>
+                <a:latin typeface="Calibri" pitchFamily="34" charset="0"/>
+                <a:ea typeface="Calibri" pitchFamily="34" charset="-122"/>
+                <a:cs typeface="Calibri" pitchFamily="34" charset="-120"/>
+              </a:rPr>
+              <a:t>PRAANA — ET AI Hackathon 2026</a:t>
+            </a:r>
+            <a:endParaRPr lang="en-US" sz="900" dirty="0"/>
           </a:p>
         </p:txBody>
       </p:sp>
@@ -12520,7 +13245,7 @@
         <p:spPr>
           <a:xfrm>
             <a:off x="594360" y="1371600"/>
-            <a:ext cx="10607040" cy="548640"/>
+            <a:ext cx="10607040" cy="502920"/>
           </a:xfrm>
           <a:prstGeom prst="rect">
             <a:avLst/>
@@ -12544,7 +13269,7 @@
                 <a:ea typeface="Calibri" pitchFamily="34" charset="-122"/>
                 <a:cs typeface="Calibri" pitchFamily="34" charset="-120"/>
               </a:rPr>
-              <a:t>Collect from sensors, satellites, weather &amp; maps → attribute pollution to its source → forecast 24–72hrs ahead → rank enforcement actions → compare across cities → communicate risk to citizens.</a:t>
+              <a:t>Collect → Attribute to source → Forecast 24–72hrs → Rank enforcement → Compare across cities → Communicate to citizens.</a:t>
             </a:r>
             <a:endParaRPr lang="en-US" sz="1250" dirty="0"/>
           </a:p>
@@ -12558,7 +13283,7 @@
         </p:nvSpPr>
         <p:spPr>
           <a:xfrm>
-            <a:off x="594360" y="2148840"/>
+            <a:off x="594360" y="2103120"/>
             <a:ext cx="1993392" cy="3611880"/>
           </a:xfrm>
           <a:prstGeom prst="roundRect">
@@ -12587,7 +13312,7 @@
         </p:nvSpPr>
         <p:spPr>
           <a:xfrm>
-            <a:off x="594360" y="2148840"/>
+            <a:off x="594360" y="2103120"/>
             <a:ext cx="1993392" cy="822960"/>
           </a:xfrm>
           <a:prstGeom prst="roundRect">
@@ -12609,7 +13334,7 @@
         </p:nvSpPr>
         <p:spPr>
           <a:xfrm>
-            <a:off x="594360" y="2651760"/>
+            <a:off x="594360" y="2606040"/>
             <a:ext cx="1993392" cy="320040"/>
           </a:xfrm>
           <a:prstGeom prst="rect">
@@ -12629,7 +13354,7 @@
         </p:nvSpPr>
         <p:spPr>
           <a:xfrm>
-            <a:off x="1307592" y="2286000"/>
+            <a:off x="1307592" y="2240280"/>
             <a:ext cx="566928" cy="566928"/>
           </a:xfrm>
           <a:prstGeom prst="ellipse">
@@ -12657,7 +13382,7 @@
         </p:blipFill>
         <p:spPr>
           <a:xfrm>
-            <a:off x="1398300" y="2376708"/>
+            <a:off x="1398300" y="2330988"/>
             <a:ext cx="385511" cy="385511"/>
           </a:xfrm>
           <a:prstGeom prst="rect">
@@ -12673,7 +13398,7 @@
         </p:nvSpPr>
         <p:spPr>
           <a:xfrm>
-            <a:off x="594360" y="3063240"/>
+            <a:off x="594360" y="3017520"/>
             <a:ext cx="1993392" cy="274320"/>
           </a:xfrm>
           <a:prstGeom prst="rect">
@@ -12712,7 +13437,7 @@
         </p:nvSpPr>
         <p:spPr>
           <a:xfrm>
-            <a:off x="722376" y="3337560"/>
+            <a:off x="722376" y="3291840"/>
             <a:ext cx="1737360" cy="868680"/>
           </a:xfrm>
           <a:prstGeom prst="rect">
@@ -12751,7 +13476,7 @@
         </p:nvSpPr>
         <p:spPr>
           <a:xfrm>
-            <a:off x="722376" y="4251960"/>
+            <a:off x="722376" y="4206240"/>
             <a:ext cx="1737360" cy="1371600"/>
           </a:xfrm>
           <a:prstGeom prst="rect">
@@ -12790,7 +13515,7 @@
         </p:nvSpPr>
         <p:spPr>
           <a:xfrm>
-            <a:off x="2752344" y="2148840"/>
+            <a:off x="2752344" y="2103120"/>
             <a:ext cx="1993392" cy="3611880"/>
           </a:xfrm>
           <a:prstGeom prst="roundRect">
@@ -12819,7 +13544,7 @@
         </p:nvSpPr>
         <p:spPr>
           <a:xfrm>
-            <a:off x="2752344" y="2148840"/>
+            <a:off x="2752344" y="2103120"/>
             <a:ext cx="1993392" cy="822960"/>
           </a:xfrm>
           <a:prstGeom prst="roundRect">
@@ -12841,7 +13566,7 @@
         </p:nvSpPr>
         <p:spPr>
           <a:xfrm>
-            <a:off x="2752344" y="2651760"/>
+            <a:off x="2752344" y="2606040"/>
             <a:ext cx="1993392" cy="320040"/>
           </a:xfrm>
           <a:prstGeom prst="rect">
@@ -12861,7 +13586,7 @@
         </p:nvSpPr>
         <p:spPr>
           <a:xfrm>
-            <a:off x="3465576" y="2286000"/>
+            <a:off x="3465576" y="2240280"/>
             <a:ext cx="566928" cy="566928"/>
           </a:xfrm>
           <a:prstGeom prst="ellipse">
@@ -12889,7 +13614,7 @@
         </p:blipFill>
         <p:spPr>
           <a:xfrm>
-            <a:off x="3556284" y="2376708"/>
+            <a:off x="3556284" y="2330988"/>
             <a:ext cx="385511" cy="385511"/>
           </a:xfrm>
           <a:prstGeom prst="rect">
@@ -12905,7 +13630,7 @@
         </p:nvSpPr>
         <p:spPr>
           <a:xfrm>
-            <a:off x="2752344" y="3063240"/>
+            <a:off x="2752344" y="3017520"/>
             <a:ext cx="1993392" cy="274320"/>
           </a:xfrm>
           <a:prstGeom prst="rect">
@@ -12944,7 +13669,7 @@
         </p:nvSpPr>
         <p:spPr>
           <a:xfrm>
-            <a:off x="2880360" y="3337560"/>
+            <a:off x="2880360" y="3291840"/>
             <a:ext cx="1737360" cy="868680"/>
           </a:xfrm>
           <a:prstGeom prst="rect">
@@ -12983,7 +13708,7 @@
         </p:nvSpPr>
         <p:spPr>
           <a:xfrm>
-            <a:off x="2880360" y="4251960"/>
+            <a:off x="2880360" y="4206240"/>
             <a:ext cx="1737360" cy="1371600"/>
           </a:xfrm>
           <a:prstGeom prst="rect">
@@ -13022,7 +13747,7 @@
         </p:nvSpPr>
         <p:spPr>
           <a:xfrm>
-            <a:off x="4910328" y="2148840"/>
+            <a:off x="4910328" y="2103120"/>
             <a:ext cx="1993392" cy="3611880"/>
           </a:xfrm>
           <a:prstGeom prst="roundRect">
@@ -13051,7 +13776,7 @@
         </p:nvSpPr>
         <p:spPr>
           <a:xfrm>
-            <a:off x="4910328" y="2148840"/>
+            <a:off x="4910328" y="2103120"/>
             <a:ext cx="1993392" cy="822960"/>
           </a:xfrm>
           <a:prstGeom prst="roundRect">
@@ -13073,7 +13798,7 @@
         </p:nvSpPr>
         <p:spPr>
           <a:xfrm>
-            <a:off x="4910328" y="2651760"/>
+            <a:off x="4910328" y="2606040"/>
             <a:ext cx="1993392" cy="320040"/>
           </a:xfrm>
           <a:prstGeom prst="rect">
@@ -13093,7 +13818,7 @@
         </p:nvSpPr>
         <p:spPr>
           <a:xfrm>
-            <a:off x="5623560" y="2286000"/>
+            <a:off x="5623560" y="2240280"/>
             <a:ext cx="566928" cy="566928"/>
           </a:xfrm>
           <a:prstGeom prst="ellipse">
@@ -13121,7 +13846,7 @@
         </p:blipFill>
         <p:spPr>
           <a:xfrm>
-            <a:off x="5714268" y="2376708"/>
+            <a:off x="5714268" y="2330988"/>
             <a:ext cx="385511" cy="385511"/>
           </a:xfrm>
           <a:prstGeom prst="rect">
@@ -13137,7 +13862,7 @@
         </p:nvSpPr>
         <p:spPr>
           <a:xfrm>
-            <a:off x="4910328" y="3063240"/>
+            <a:off x="4910328" y="3017520"/>
             <a:ext cx="1993392" cy="274320"/>
           </a:xfrm>
           <a:prstGeom prst="rect">
@@ -13176,7 +13901,7 @@
         </p:nvSpPr>
         <p:spPr>
           <a:xfrm>
-            <a:off x="5038344" y="3337560"/>
+            <a:off x="5038344" y="3291840"/>
             <a:ext cx="1737360" cy="868680"/>
           </a:xfrm>
           <a:prstGeom prst="rect">
@@ -13215,7 +13940,7 @@
         </p:nvSpPr>
         <p:spPr>
           <a:xfrm>
-            <a:off x="5038344" y="4251960"/>
+            <a:off x="5038344" y="4206240"/>
             <a:ext cx="1737360" cy="1371600"/>
           </a:xfrm>
           <a:prstGeom prst="rect">
@@ -13254,7 +13979,7 @@
         </p:nvSpPr>
         <p:spPr>
           <a:xfrm>
-            <a:off x="7068312" y="2148840"/>
+            <a:off x="7068312" y="2103120"/>
             <a:ext cx="1993392" cy="3611880"/>
           </a:xfrm>
           <a:prstGeom prst="roundRect">
@@ -13283,7 +14008,7 @@
         </p:nvSpPr>
         <p:spPr>
           <a:xfrm>
-            <a:off x="7068312" y="2148840"/>
+            <a:off x="7068312" y="2103120"/>
             <a:ext cx="1993392" cy="822960"/>
           </a:xfrm>
           <a:prstGeom prst="roundRect">
@@ -13305,7 +14030,7 @@
         </p:nvSpPr>
         <p:spPr>
           <a:xfrm>
-            <a:off x="7068312" y="2651760"/>
+            <a:off x="7068312" y="2606040"/>
             <a:ext cx="1993392" cy="320040"/>
           </a:xfrm>
           <a:prstGeom prst="rect">
@@ -13325,7 +14050,7 @@
         </p:nvSpPr>
         <p:spPr>
           <a:xfrm>
-            <a:off x="7781544" y="2286000"/>
+            <a:off x="7781544" y="2240280"/>
             <a:ext cx="566928" cy="566928"/>
           </a:xfrm>
           <a:prstGeom prst="ellipse">
@@ -13353,7 +14078,7 @@
         </p:blipFill>
         <p:spPr>
           <a:xfrm>
-            <a:off x="7872252" y="2376708"/>
+            <a:off x="7872252" y="2330988"/>
             <a:ext cx="385511" cy="385511"/>
           </a:xfrm>
           <a:prstGeom prst="rect">
@@ -13369,7 +14094,7 @@
         </p:nvSpPr>
         <p:spPr>
           <a:xfrm>
-            <a:off x="7068312" y="3063240"/>
+            <a:off x="7068312" y="3017520"/>
             <a:ext cx="1993392" cy="274320"/>
           </a:xfrm>
           <a:prstGeom prst="rect">
@@ -13408,7 +14133,7 @@
         </p:nvSpPr>
         <p:spPr>
           <a:xfrm>
-            <a:off x="7196328" y="3337560"/>
+            <a:off x="7196328" y="3291840"/>
             <a:ext cx="1737360" cy="868680"/>
           </a:xfrm>
           <a:prstGeom prst="rect">
@@ -13447,7 +14172,7 @@
         </p:nvSpPr>
         <p:spPr>
           <a:xfrm>
-            <a:off x="7196328" y="4251960"/>
+            <a:off x="7196328" y="4206240"/>
             <a:ext cx="1737360" cy="1371600"/>
           </a:xfrm>
           <a:prstGeom prst="rect">
@@ -13486,7 +14211,7 @@
         </p:nvSpPr>
         <p:spPr>
           <a:xfrm>
-            <a:off x="9226296" y="2148840"/>
+            <a:off x="9226296" y="2103120"/>
             <a:ext cx="1993392" cy="3611880"/>
           </a:xfrm>
           <a:prstGeom prst="roundRect">
@@ -13515,7 +14240,7 @@
         </p:nvSpPr>
         <p:spPr>
           <a:xfrm>
-            <a:off x="9226296" y="2148840"/>
+            <a:off x="9226296" y="2103120"/>
             <a:ext cx="1993392" cy="822960"/>
           </a:xfrm>
           <a:prstGeom prst="roundRect">
@@ -13537,7 +14262,7 @@
         </p:nvSpPr>
         <p:spPr>
           <a:xfrm>
-            <a:off x="9226296" y="2651760"/>
+            <a:off x="9226296" y="2606040"/>
             <a:ext cx="1993392" cy="320040"/>
           </a:xfrm>
           <a:prstGeom prst="rect">
@@ -13557,7 +14282,7 @@
         </p:nvSpPr>
         <p:spPr>
           <a:xfrm>
-            <a:off x="9939528" y="2286000"/>
+            <a:off x="9939528" y="2240280"/>
             <a:ext cx="566928" cy="566928"/>
           </a:xfrm>
           <a:prstGeom prst="ellipse">
@@ -13585,7 +14310,7 @@
         </p:blipFill>
         <p:spPr>
           <a:xfrm>
-            <a:off x="10030236" y="2376708"/>
+            <a:off x="10030236" y="2330988"/>
             <a:ext cx="385511" cy="385511"/>
           </a:xfrm>
           <a:prstGeom prst="rect">
@@ -13601,7 +14326,7 @@
         </p:nvSpPr>
         <p:spPr>
           <a:xfrm>
-            <a:off x="9226296" y="3063240"/>
+            <a:off x="9226296" y="3017520"/>
             <a:ext cx="1993392" cy="274320"/>
           </a:xfrm>
           <a:prstGeom prst="rect">
@@ -13640,7 +14365,7 @@
         </p:nvSpPr>
         <p:spPr>
           <a:xfrm>
-            <a:off x="9354312" y="3337560"/>
+            <a:off x="9354312" y="3291840"/>
             <a:ext cx="1737360" cy="868680"/>
           </a:xfrm>
           <a:prstGeom prst="rect">
@@ -13679,7 +14404,7 @@
         </p:nvSpPr>
         <p:spPr>
           <a:xfrm>
-            <a:off x="9354312" y="4251960"/>
+            <a:off x="9354312" y="4206240"/>
             <a:ext cx="1737360" cy="1371600"/>
           </a:xfrm>
           <a:prstGeom prst="rect">
@@ -13707,6 +14432,84 @@
               <a:t>Regional-language alerts via app &amp; IVR</a:t>
             </a:r>
             <a:endParaRPr lang="en-US" sz="1000" dirty="0"/>
+          </a:p>
+        </p:txBody>
+      </p:sp>
+      <p:sp>
+        <p:nvSpPr>
+          <p:cNvPr id="45" name="Text 38"/>
+          <p:cNvSpPr/>
+          <p:nvPr/>
+        </p:nvSpPr>
+        <p:spPr>
+          <a:xfrm>
+            <a:off x="11002975" y="6419088"/>
+            <a:ext cx="822960" cy="274320"/>
+          </a:xfrm>
+          <a:prstGeom prst="rect">
+            <a:avLst/>
+          </a:prstGeom>
+          <a:noFill/>
+          <a:ln/>
+        </p:spPr>
+        <p:txBody>
+          <a:bodyPr wrap="square" lIns="0" tIns="0" rIns="0" bIns="0" rtlCol="0" anchor="ctr"/>
+          <a:lstStyle/>
+          <a:p>
+            <a:pPr marL="0" indent="0" algn="r">
+              <a:buNone/>
+            </a:pPr>
+            <a:r>
+              <a:rPr lang="en-US" sz="900" dirty="0">
+                <a:solidFill>
+                  <a:srgbClr val="5C6B73"/>
+                </a:solidFill>
+                <a:latin typeface="Calibri" pitchFamily="34" charset="0"/>
+                <a:ea typeface="Calibri" pitchFamily="34" charset="-122"/>
+                <a:cs typeface="Calibri" pitchFamily="34" charset="-120"/>
+              </a:rPr>
+              <a:t>04 / 16</a:t>
+            </a:r>
+            <a:endParaRPr lang="en-US" sz="900" dirty="0"/>
+          </a:p>
+        </p:txBody>
+      </p:sp>
+      <p:sp>
+        <p:nvSpPr>
+          <p:cNvPr id="46" name="Text 39"/>
+          <p:cNvSpPr/>
+          <p:nvPr/>
+        </p:nvSpPr>
+        <p:spPr>
+          <a:xfrm>
+            <a:off x="594360" y="6419088"/>
+            <a:ext cx="4572000" cy="274320"/>
+          </a:xfrm>
+          <a:prstGeom prst="rect">
+            <a:avLst/>
+          </a:prstGeom>
+          <a:noFill/>
+          <a:ln/>
+        </p:spPr>
+        <p:txBody>
+          <a:bodyPr wrap="square" lIns="0" tIns="0" rIns="0" bIns="0" rtlCol="0" anchor="ctr"/>
+          <a:lstStyle/>
+          <a:p>
+            <a:pPr marL="0" indent="0">
+              <a:buNone/>
+            </a:pPr>
+            <a:r>
+              <a:rPr lang="en-US" sz="900" dirty="0">
+                <a:solidFill>
+                  <a:srgbClr val="5C6B73"/>
+                </a:solidFill>
+                <a:latin typeface="Calibri" pitchFamily="34" charset="0"/>
+                <a:ea typeface="Calibri" pitchFamily="34" charset="-122"/>
+                <a:cs typeface="Calibri" pitchFamily="34" charset="-120"/>
+              </a:rPr>
+              <a:t>PRAANA — ET AI Hackathon 2026</a:t>
+            </a:r>
+            <a:endParaRPr lang="en-US" sz="900" dirty="0"/>
           </a:p>
         </p:txBody>
       </p:sp>
@@ -13815,7 +14618,7 @@
                 <a:ea typeface="Cambria" pitchFamily="34" charset="-122"/>
                 <a:cs typeface="Cambria" pitchFamily="34" charset="-120"/>
               </a:rPr>
-              <a:t>From Six Data Sources to Two Action Surfaces</a:t>
+              <a:t>From Five Data Sources to Three Action Surfaces</a:t>
             </a:r>
             <a:endParaRPr lang="en-US" sz="2800" dirty="0"/>
           </a:p>
@@ -13823,7 +14626,7 @@
       </p:sp>
       <p:pic>
         <p:nvPicPr>
-          <p:cNvPr id="4" name="Image 0" descr="/home/claude/praana/architecture_diagram.png"/>
+          <p:cNvPr id="4" name="Image 0" descr="/home/claude/praana2/arch_user.png"/>
           <p:cNvPicPr>
             <a:picLocks noChangeAspect="1"/>
           </p:cNvPicPr>
@@ -13845,6 +14648,84 @@
           </a:prstGeom>
         </p:spPr>
       </p:pic>
+      <p:sp>
+        <p:nvSpPr>
+          <p:cNvPr id="5" name="Text 2"/>
+          <p:cNvSpPr/>
+          <p:nvPr/>
+        </p:nvSpPr>
+        <p:spPr>
+          <a:xfrm>
+            <a:off x="11002975" y="6419088"/>
+            <a:ext cx="822960" cy="274320"/>
+          </a:xfrm>
+          <a:prstGeom prst="rect">
+            <a:avLst/>
+          </a:prstGeom>
+          <a:noFill/>
+          <a:ln/>
+        </p:spPr>
+        <p:txBody>
+          <a:bodyPr wrap="square" lIns="0" tIns="0" rIns="0" bIns="0" rtlCol="0" anchor="ctr"/>
+          <a:lstStyle/>
+          <a:p>
+            <a:pPr marL="0" indent="0" algn="r">
+              <a:buNone/>
+            </a:pPr>
+            <a:r>
+              <a:rPr lang="en-US" sz="900" dirty="0">
+                <a:solidFill>
+                  <a:srgbClr val="5C6B73"/>
+                </a:solidFill>
+                <a:latin typeface="Calibri" pitchFamily="34" charset="0"/>
+                <a:ea typeface="Calibri" pitchFamily="34" charset="-122"/>
+                <a:cs typeface="Calibri" pitchFamily="34" charset="-120"/>
+              </a:rPr>
+              <a:t>05 / 16</a:t>
+            </a:r>
+            <a:endParaRPr lang="en-US" sz="900" dirty="0"/>
+          </a:p>
+        </p:txBody>
+      </p:sp>
+      <p:sp>
+        <p:nvSpPr>
+          <p:cNvPr id="6" name="Text 3"/>
+          <p:cNvSpPr/>
+          <p:nvPr/>
+        </p:nvSpPr>
+        <p:spPr>
+          <a:xfrm>
+            <a:off x="594360" y="6419088"/>
+            <a:ext cx="4572000" cy="274320"/>
+          </a:xfrm>
+          <a:prstGeom prst="rect">
+            <a:avLst/>
+          </a:prstGeom>
+          <a:noFill/>
+          <a:ln/>
+        </p:spPr>
+        <p:txBody>
+          <a:bodyPr wrap="square" lIns="0" tIns="0" rIns="0" bIns="0" rtlCol="0" anchor="ctr"/>
+          <a:lstStyle/>
+          <a:p>
+            <a:pPr marL="0" indent="0">
+              <a:buNone/>
+            </a:pPr>
+            <a:r>
+              <a:rPr lang="en-US" sz="900" dirty="0">
+                <a:solidFill>
+                  <a:srgbClr val="5C6B73"/>
+                </a:solidFill>
+                <a:latin typeface="Calibri" pitchFamily="34" charset="0"/>
+                <a:ea typeface="Calibri" pitchFamily="34" charset="-122"/>
+                <a:cs typeface="Calibri" pitchFamily="34" charset="-120"/>
+              </a:rPr>
+              <a:t>PRAANA — ET AI Hackathon 2026</a:t>
+            </a:r>
+            <a:endParaRPr lang="en-US" sz="900" dirty="0"/>
+          </a:p>
+        </p:txBody>
+      </p:sp>
     </p:spTree>
   </p:cSld>
   <p:clrMapOvr>
@@ -14862,6 +15743,84 @@
           </a:p>
         </p:txBody>
       </p:sp>
+      <p:sp>
+        <p:nvSpPr>
+          <p:cNvPr id="34" name="Text 26"/>
+          <p:cNvSpPr/>
+          <p:nvPr/>
+        </p:nvSpPr>
+        <p:spPr>
+          <a:xfrm>
+            <a:off x="11002975" y="6419088"/>
+            <a:ext cx="822960" cy="274320"/>
+          </a:xfrm>
+          <a:prstGeom prst="rect">
+            <a:avLst/>
+          </a:prstGeom>
+          <a:noFill/>
+          <a:ln/>
+        </p:spPr>
+        <p:txBody>
+          <a:bodyPr wrap="square" lIns="0" tIns="0" rIns="0" bIns="0" rtlCol="0" anchor="ctr"/>
+          <a:lstStyle/>
+          <a:p>
+            <a:pPr marL="0" indent="0" algn="r">
+              <a:buNone/>
+            </a:pPr>
+            <a:r>
+              <a:rPr lang="en-US" sz="900" dirty="0">
+                <a:solidFill>
+                  <a:srgbClr val="5C6B73"/>
+                </a:solidFill>
+                <a:latin typeface="Calibri" pitchFamily="34" charset="0"/>
+                <a:ea typeface="Calibri" pitchFamily="34" charset="-122"/>
+                <a:cs typeface="Calibri" pitchFamily="34" charset="-120"/>
+              </a:rPr>
+              <a:t>06 / 16</a:t>
+            </a:r>
+            <a:endParaRPr lang="en-US" sz="900" dirty="0"/>
+          </a:p>
+        </p:txBody>
+      </p:sp>
+      <p:sp>
+        <p:nvSpPr>
+          <p:cNvPr id="35" name="Text 27"/>
+          <p:cNvSpPr/>
+          <p:nvPr/>
+        </p:nvSpPr>
+        <p:spPr>
+          <a:xfrm>
+            <a:off x="594360" y="6419088"/>
+            <a:ext cx="4572000" cy="274320"/>
+          </a:xfrm>
+          <a:prstGeom prst="rect">
+            <a:avLst/>
+          </a:prstGeom>
+          <a:noFill/>
+          <a:ln/>
+        </p:spPr>
+        <p:txBody>
+          <a:bodyPr wrap="square" lIns="0" tIns="0" rIns="0" bIns="0" rtlCol="0" anchor="ctr"/>
+          <a:lstStyle/>
+          <a:p>
+            <a:pPr marL="0" indent="0">
+              <a:buNone/>
+            </a:pPr>
+            <a:r>
+              <a:rPr lang="en-US" sz="900" dirty="0">
+                <a:solidFill>
+                  <a:srgbClr val="5C6B73"/>
+                </a:solidFill>
+                <a:latin typeface="Calibri" pitchFamily="34" charset="0"/>
+                <a:ea typeface="Calibri" pitchFamily="34" charset="-122"/>
+                <a:cs typeface="Calibri" pitchFamily="34" charset="-120"/>
+              </a:rPr>
+              <a:t>PRAANA — ET AI Hackathon 2026</a:t>
+            </a:r>
+            <a:endParaRPr lang="en-US" sz="900" dirty="0"/>
+          </a:p>
+        </p:txBody>
+      </p:sp>
     </p:spTree>
   </p:cSld>
   <p:clrMapOvr>
@@ -15002,7 +15961,7 @@
         <p:spPr>
           <a:xfrm>
             <a:off x="850392" y="1728216"/>
-            <a:ext cx="5669280" cy="457200"/>
+            <a:ext cx="5394960" cy="457200"/>
           </a:xfrm>
           <a:prstGeom prst="rect">
             <a:avLst/>
@@ -15061,7 +16020,7 @@
         <p:spPr>
           <a:xfrm>
             <a:off x="850392" y="2258568"/>
-            <a:ext cx="5669280" cy="457200"/>
+            <a:ext cx="5394960" cy="457200"/>
           </a:xfrm>
           <a:prstGeom prst="rect">
             <a:avLst/>
@@ -15120,7 +16079,7 @@
         <p:spPr>
           <a:xfrm>
             <a:off x="850392" y="2788920"/>
-            <a:ext cx="5669280" cy="457200"/>
+            <a:ext cx="5394960" cy="457200"/>
           </a:xfrm>
           <a:prstGeom prst="rect">
             <a:avLst/>
@@ -15179,7 +16138,7 @@
         <p:spPr>
           <a:xfrm>
             <a:off x="850392" y="3319272"/>
-            <a:ext cx="5669280" cy="457200"/>
+            <a:ext cx="5394960" cy="457200"/>
           </a:xfrm>
           <a:prstGeom prst="rect">
             <a:avLst/>
@@ -15218,7 +16177,7 @@
         <p:spPr>
           <a:xfrm>
             <a:off x="594360" y="3950208"/>
-            <a:ext cx="5943600" cy="1417320"/>
+            <a:ext cx="5669280" cy="1417320"/>
           </a:xfrm>
           <a:prstGeom prst="roundRect">
             <a:avLst>
@@ -15247,7 +16206,7 @@
         <p:spPr>
           <a:xfrm>
             <a:off x="795528" y="4087368"/>
-            <a:ext cx="5541264" cy="320040"/>
+            <a:ext cx="5303520" cy="320040"/>
           </a:xfrm>
           <a:prstGeom prst="rect">
             <a:avLst/>
@@ -15285,8 +16244,8 @@
         </p:nvSpPr>
         <p:spPr>
           <a:xfrm>
-            <a:off x="795528" y="4434840"/>
-            <a:ext cx="5541264" cy="868680"/>
+            <a:off x="795528" y="4453128"/>
+            <a:ext cx="5303520" cy="822960"/>
           </a:xfrm>
           <a:prstGeom prst="rect">
             <a:avLst/>
@@ -15310,7 +16269,7 @@
                 <a:ea typeface="Calibri" pitchFamily="34" charset="-122"/>
                 <a:cs typeface="Calibri" pitchFamily="34" charset="-120"/>
               </a:rPr>
-              <a:t>PM10 spikes downwind of a known construction site, confirmed against live wind direction — not just correlated with nearby traffic.</a:t>
+              <a:t>PM10 spikes downwind of a known construction site, confirmed against live wind direction — not misattributed to local traffic.</a:t>
             </a:r>
             <a:endParaRPr lang="en-US" sz="1150" dirty="0"/>
           </a:p>
@@ -15324,12 +16283,12 @@
         </p:nvSpPr>
         <p:spPr>
           <a:xfrm>
-            <a:off x="6858000" y="1783080"/>
-            <a:ext cx="4206240" cy="4251960"/>
+            <a:off x="6537960" y="1783080"/>
+            <a:ext cx="5059375" cy="4251960"/>
           </a:xfrm>
           <a:prstGeom prst="roundRect">
             <a:avLst>
-              <a:gd name="adj" fmla="val 1957"/>
+              <a:gd name="adj" fmla="val 1935"/>
             </a:avLst>
           </a:prstGeom>
           <a:solidFill>
@@ -15353,8 +16312,8 @@
         </p:nvSpPr>
         <p:spPr>
           <a:xfrm>
-            <a:off x="7086600" y="1920240"/>
-            <a:ext cx="3749040" cy="320040"/>
+            <a:off x="6766560" y="1920240"/>
+            <a:ext cx="4602175" cy="320040"/>
           </a:xfrm>
           <a:prstGeom prst="rect">
             <a:avLst/>
@@ -15391,8 +16350,8 @@
           <p:nvPr/>
         </p:nvGraphicFramePr>
         <p:xfrm>
-          <a:off x="7178040" y="2286000"/>
-          <a:ext cx="3566160" cy="2743200"/>
+          <a:off x="6858000" y="2286000"/>
+          <a:ext cx="4419295" cy="2743200"/>
         </p:xfrm>
         <a:graphic>
           <a:graphicData uri="http://schemas.openxmlformats.org/drawingml/2006/chart">
@@ -15408,8 +16367,8 @@
         </p:nvSpPr>
         <p:spPr>
           <a:xfrm>
-            <a:off x="7086600" y="5257800"/>
-            <a:ext cx="3749040" cy="274320"/>
+            <a:off x="6766560" y="5257800"/>
+            <a:ext cx="4602175" cy="274320"/>
           </a:xfrm>
           <a:prstGeom prst="rect">
             <a:avLst/>
@@ -15434,6 +16393,84 @@
                 <a:cs typeface="Calibri" pitchFamily="34" charset="-120"/>
               </a:rPr>
               <a:t>PM2.5=180 · PM10=220 · NO2=85 · SO2=12 · CO=45</a:t>
+            </a:r>
+            <a:endParaRPr lang="en-US" sz="900" dirty="0"/>
+          </a:p>
+        </p:txBody>
+      </p:sp>
+      <p:sp>
+        <p:nvSpPr>
+          <p:cNvPr id="19" name="Text 16"/>
+          <p:cNvSpPr/>
+          <p:nvPr/>
+        </p:nvSpPr>
+        <p:spPr>
+          <a:xfrm>
+            <a:off x="11002975" y="6419088"/>
+            <a:ext cx="822960" cy="274320"/>
+          </a:xfrm>
+          <a:prstGeom prst="rect">
+            <a:avLst/>
+          </a:prstGeom>
+          <a:noFill/>
+          <a:ln/>
+        </p:spPr>
+        <p:txBody>
+          <a:bodyPr wrap="square" lIns="0" tIns="0" rIns="0" bIns="0" rtlCol="0" anchor="ctr"/>
+          <a:lstStyle/>
+          <a:p>
+            <a:pPr marL="0" indent="0" algn="r">
+              <a:buNone/>
+            </a:pPr>
+            <a:r>
+              <a:rPr lang="en-US" sz="900" dirty="0">
+                <a:solidFill>
+                  <a:srgbClr val="5C6B73"/>
+                </a:solidFill>
+                <a:latin typeface="Calibri" pitchFamily="34" charset="0"/>
+                <a:ea typeface="Calibri" pitchFamily="34" charset="-122"/>
+                <a:cs typeface="Calibri" pitchFamily="34" charset="-120"/>
+              </a:rPr>
+              <a:t>07 / 16</a:t>
+            </a:r>
+            <a:endParaRPr lang="en-US" sz="900" dirty="0"/>
+          </a:p>
+        </p:txBody>
+      </p:sp>
+      <p:sp>
+        <p:nvSpPr>
+          <p:cNvPr id="20" name="Text 17"/>
+          <p:cNvSpPr/>
+          <p:nvPr/>
+        </p:nvSpPr>
+        <p:spPr>
+          <a:xfrm>
+            <a:off x="594360" y="6419088"/>
+            <a:ext cx="4572000" cy="274320"/>
+          </a:xfrm>
+          <a:prstGeom prst="rect">
+            <a:avLst/>
+          </a:prstGeom>
+          <a:noFill/>
+          <a:ln/>
+        </p:spPr>
+        <p:txBody>
+          <a:bodyPr wrap="square" lIns="0" tIns="0" rIns="0" bIns="0" rtlCol="0" anchor="ctr"/>
+          <a:lstStyle/>
+          <a:p>
+            <a:pPr marL="0" indent="0">
+              <a:buNone/>
+            </a:pPr>
+            <a:r>
+              <a:rPr lang="en-US" sz="900" dirty="0">
+                <a:solidFill>
+                  <a:srgbClr val="5C6B73"/>
+                </a:solidFill>
+                <a:latin typeface="Calibri" pitchFamily="34" charset="0"/>
+                <a:ea typeface="Calibri" pitchFamily="34" charset="-122"/>
+                <a:cs typeface="Calibri" pitchFamily="34" charset="-120"/>
+              </a:rPr>
+              <a:t>PRAANA — ET AI Hackathon 2026</a:t>
             </a:r>
             <a:endParaRPr lang="en-US" sz="900" dirty="0"/>
           </a:p>
@@ -15603,7 +16640,7 @@
         <p:spPr>
           <a:xfrm>
             <a:off x="1124712" y="1773936"/>
-            <a:ext cx="4956048" cy="868680"/>
+            <a:ext cx="4407408" cy="868680"/>
           </a:xfrm>
           <a:prstGeom prst="rect">
             <a:avLst/>
@@ -15686,7 +16723,7 @@
         <p:spPr>
           <a:xfrm>
             <a:off x="1124712" y="2852928"/>
-            <a:ext cx="4956048" cy="868680"/>
+            <a:ext cx="4407408" cy="868680"/>
           </a:xfrm>
           <a:prstGeom prst="rect">
             <a:avLst/>
@@ -15710,7 +16747,7 @@
                 <a:ea typeface="Calibri" pitchFamily="34" charset="-122"/>
                 <a:cs typeface="Calibri" pitchFamily="34" charset="-120"/>
               </a:rPr>
-              <a:t>Blended with a physics-based atmospheric dispersion model so predictions stay grounded, not just pattern-matched.</a:t>
+              <a:t>Blended with a physics-based atmospheric dispersion model so predictions stay physically grounded, not just pattern-matched.</a:t>
             </a:r>
             <a:endParaRPr lang="en-US" sz="1250" dirty="0"/>
           </a:p>
@@ -15769,7 +16806,7 @@
         <p:spPr>
           <a:xfrm>
             <a:off x="1124712" y="3931920"/>
-            <a:ext cx="4956048" cy="868680"/>
+            <a:ext cx="4407408" cy="868680"/>
           </a:xfrm>
           <a:prstGeom prst="rect">
             <a:avLst/>
@@ -15807,8 +16844,8 @@
         </p:nvSpPr>
         <p:spPr>
           <a:xfrm>
-            <a:off x="6446520" y="1783080"/>
-            <a:ext cx="5150815" cy="4251960"/>
+            <a:off x="5715000" y="1783080"/>
+            <a:ext cx="5882335" cy="4251960"/>
           </a:xfrm>
           <a:prstGeom prst="roundRect">
             <a:avLst>
@@ -15836,8 +16873,8 @@
         </p:nvSpPr>
         <p:spPr>
           <a:xfrm>
-            <a:off x="6675120" y="1920240"/>
-            <a:ext cx="4693615" cy="320040"/>
+            <a:off x="5943600" y="1920240"/>
+            <a:ext cx="5425135" cy="320040"/>
           </a:xfrm>
           <a:prstGeom prst="rect">
             <a:avLst/>
@@ -15874,8 +16911,8 @@
           <p:nvPr/>
         </p:nvGraphicFramePr>
         <p:xfrm>
-          <a:off x="6720840" y="2331720"/>
-          <a:ext cx="4602175" cy="3383280"/>
+          <a:off x="5989320" y="2331720"/>
+          <a:ext cx="5333695" cy="3383280"/>
         </p:xfrm>
         <a:graphic>
           <a:graphicData uri="http://schemas.openxmlformats.org/drawingml/2006/chart">
@@ -15883,6 +16920,84 @@
           </a:graphicData>
         </a:graphic>
       </p:graphicFrame>
+      <p:sp>
+        <p:nvSpPr>
+          <p:cNvPr id="16" name="Text 10"/>
+          <p:cNvSpPr/>
+          <p:nvPr/>
+        </p:nvSpPr>
+        <p:spPr>
+          <a:xfrm>
+            <a:off x="11002975" y="6419088"/>
+            <a:ext cx="822960" cy="274320"/>
+          </a:xfrm>
+          <a:prstGeom prst="rect">
+            <a:avLst/>
+          </a:prstGeom>
+          <a:noFill/>
+          <a:ln/>
+        </p:spPr>
+        <p:txBody>
+          <a:bodyPr wrap="square" lIns="0" tIns="0" rIns="0" bIns="0" rtlCol="0" anchor="ctr"/>
+          <a:lstStyle/>
+          <a:p>
+            <a:pPr marL="0" indent="0" algn="r">
+              <a:buNone/>
+            </a:pPr>
+            <a:r>
+              <a:rPr lang="en-US" sz="900" dirty="0">
+                <a:solidFill>
+                  <a:srgbClr val="5C6B73"/>
+                </a:solidFill>
+                <a:latin typeface="Calibri" pitchFamily="34" charset="0"/>
+                <a:ea typeface="Calibri" pitchFamily="34" charset="-122"/>
+                <a:cs typeface="Calibri" pitchFamily="34" charset="-120"/>
+              </a:rPr>
+              <a:t>08 / 16</a:t>
+            </a:r>
+            <a:endParaRPr lang="en-US" sz="900" dirty="0"/>
+          </a:p>
+        </p:txBody>
+      </p:sp>
+      <p:sp>
+        <p:nvSpPr>
+          <p:cNvPr id="17" name="Text 11"/>
+          <p:cNvSpPr/>
+          <p:nvPr/>
+        </p:nvSpPr>
+        <p:spPr>
+          <a:xfrm>
+            <a:off x="594360" y="6419088"/>
+            <a:ext cx="4572000" cy="274320"/>
+          </a:xfrm>
+          <a:prstGeom prst="rect">
+            <a:avLst/>
+          </a:prstGeom>
+          <a:noFill/>
+          <a:ln/>
+        </p:spPr>
+        <p:txBody>
+          <a:bodyPr wrap="square" lIns="0" tIns="0" rIns="0" bIns="0" rtlCol="0" anchor="ctr"/>
+          <a:lstStyle/>
+          <a:p>
+            <a:pPr marL="0" indent="0">
+              <a:buNone/>
+            </a:pPr>
+            <a:r>
+              <a:rPr lang="en-US" sz="900" dirty="0">
+                <a:solidFill>
+                  <a:srgbClr val="5C6B73"/>
+                </a:solidFill>
+                <a:latin typeface="Calibri" pitchFamily="34" charset="0"/>
+                <a:ea typeface="Calibri" pitchFamily="34" charset="-122"/>
+                <a:cs typeface="Calibri" pitchFamily="34" charset="-120"/>
+              </a:rPr>
+              <a:t>PRAANA — ET AI Hackathon 2026</a:t>
+            </a:r>
+            <a:endParaRPr lang="en-US" sz="900" dirty="0"/>
+          </a:p>
+        </p:txBody>
+      </p:sp>
     </p:spTree>
   </p:cSld>
   <p:clrMapOvr>
@@ -16615,6 +17730,84 @@
           </a:graphicData>
         </a:graphic>
       </p:graphicFrame>
+      <p:sp>
+        <p:nvSpPr>
+          <p:cNvPr id="23" name="Text 20"/>
+          <p:cNvSpPr/>
+          <p:nvPr/>
+        </p:nvSpPr>
+        <p:spPr>
+          <a:xfrm>
+            <a:off x="11002975" y="6419088"/>
+            <a:ext cx="822960" cy="274320"/>
+          </a:xfrm>
+          <a:prstGeom prst="rect">
+            <a:avLst/>
+          </a:prstGeom>
+          <a:noFill/>
+          <a:ln/>
+        </p:spPr>
+        <p:txBody>
+          <a:bodyPr wrap="square" lIns="0" tIns="0" rIns="0" bIns="0" rtlCol="0" anchor="ctr"/>
+          <a:lstStyle/>
+          <a:p>
+            <a:pPr marL="0" indent="0" algn="r">
+              <a:buNone/>
+            </a:pPr>
+            <a:r>
+              <a:rPr lang="en-US" sz="900" dirty="0">
+                <a:solidFill>
+                  <a:srgbClr val="5C6B73"/>
+                </a:solidFill>
+                <a:latin typeface="Calibri" pitchFamily="34" charset="0"/>
+                <a:ea typeface="Calibri" pitchFamily="34" charset="-122"/>
+                <a:cs typeface="Calibri" pitchFamily="34" charset="-120"/>
+              </a:rPr>
+              <a:t>09 / 16</a:t>
+            </a:r>
+            <a:endParaRPr lang="en-US" sz="900" dirty="0"/>
+          </a:p>
+        </p:txBody>
+      </p:sp>
+      <p:sp>
+        <p:nvSpPr>
+          <p:cNvPr id="24" name="Text 21"/>
+          <p:cNvSpPr/>
+          <p:nvPr/>
+        </p:nvSpPr>
+        <p:spPr>
+          <a:xfrm>
+            <a:off x="594360" y="6419088"/>
+            <a:ext cx="4572000" cy="274320"/>
+          </a:xfrm>
+          <a:prstGeom prst="rect">
+            <a:avLst/>
+          </a:prstGeom>
+          <a:noFill/>
+          <a:ln/>
+        </p:spPr>
+        <p:txBody>
+          <a:bodyPr wrap="square" lIns="0" tIns="0" rIns="0" bIns="0" rtlCol="0" anchor="ctr"/>
+          <a:lstStyle/>
+          <a:p>
+            <a:pPr marL="0" indent="0">
+              <a:buNone/>
+            </a:pPr>
+            <a:r>
+              <a:rPr lang="en-US" sz="900" dirty="0">
+                <a:solidFill>
+                  <a:srgbClr val="5C6B73"/>
+                </a:solidFill>
+                <a:latin typeface="Calibri" pitchFamily="34" charset="0"/>
+                <a:ea typeface="Calibri" pitchFamily="34" charset="-122"/>
+                <a:cs typeface="Calibri" pitchFamily="34" charset="-120"/>
+              </a:rPr>
+              <a:t>PRAANA — ET AI Hackathon 2026</a:t>
+            </a:r>
+            <a:endParaRPr lang="en-US" sz="900" dirty="0"/>
+          </a:p>
+        </p:txBody>
+      </p:sp>
     </p:spTree>
   </p:cSld>
   <p:clrMapOvr>

</xml_diff>

<commit_message>
Fix OSM Overpass timeout — add mirror fallback servers
</commit_message>
<xml_diff>
--- a/docs/PRAANA_Pitch_Deck.pptx
+++ b/docs/PRAANA_Pitch_Deck.pptx
@@ -4098,7 +4098,7 @@
                 <a:ea typeface="Calibri" pitchFamily="34" charset="-122"/>
                 <a:cs typeface="Calibri" pitchFamily="34" charset="-120"/>
               </a:rPr>
-              <a:t>Same ward-hour feature table, any city — onboarding needs a new CAAQMS feed, not new modelling.</a:t>
+              <a:t>Live basic AQI comparison across all 5 cities today; deeper per-city validation (forecast models, wind-check) is the roadmap, not onboarding.</a:t>
             </a:r>
             <a:endParaRPr lang="en-US" sz="1250" dirty="0"/>
           </a:p>
@@ -4249,7 +4249,7 @@
                 <a:ea typeface="Calibri" pitchFamily="34" charset="-122"/>
                 <a:cs typeface="Calibri" pitchFamily="34" charset="-120"/>
               </a:rPr>
-              <a:t>Live — primary build</a:t>
+              <a:t>Live — deepest validation (forecast + wind-check)</a:t>
             </a:r>
             <a:endParaRPr lang="en-US" sz="950" dirty="0"/>
           </a:p>
@@ -4400,7 +4400,7 @@
                 <a:ea typeface="Calibri" pitchFamily="34" charset="-122"/>
                 <a:cs typeface="Calibri" pitchFamily="34" charset="-120"/>
               </a:rPr>
-              <a:t>Live — comparison city</a:t>
+              <a:t>Live — deepest validation (forecast + wind-check)</a:t>
             </a:r>
             <a:endParaRPr lang="en-US" sz="950" dirty="0"/>
           </a:p>
@@ -4551,7 +4551,7 @@
                 <a:ea typeface="Calibri" pitchFamily="34" charset="-122"/>
                 <a:cs typeface="Calibri" pitchFamily="34" charset="-120"/>
               </a:rPr>
-              <a:t>Next onboarding wave</a:t>
+              <a:t>Live — basic comparison (deep validation is roadmap)</a:t>
             </a:r>
             <a:endParaRPr lang="en-US" sz="950" dirty="0"/>
           </a:p>
@@ -4702,7 +4702,7 @@
                 <a:ea typeface="Calibri" pitchFamily="34" charset="-122"/>
                 <a:cs typeface="Calibri" pitchFamily="34" charset="-120"/>
               </a:rPr>
-              <a:t>Next onboarding wave</a:t>
+              <a:t>Live — basic comparison (deep validation is roadmap)</a:t>
             </a:r>
             <a:endParaRPr lang="en-US" sz="950" dirty="0"/>
           </a:p>
@@ -4853,7 +4853,7 @@
                 <a:ea typeface="Calibri" pitchFamily="34" charset="-122"/>
                 <a:cs typeface="Calibri" pitchFamily="34" charset="-120"/>
               </a:rPr>
-              <a:t>Next onboarding wave</a:t>
+              <a:t>Live — basic comparison (deep validation is roadmap)</a:t>
             </a:r>
             <a:endParaRPr lang="en-US" sz="950" dirty="0"/>
           </a:p>
@@ -5398,7 +5398,7 @@
                 <a:ea typeface="Calibri" pitchFamily="34" charset="-122"/>
                 <a:cs typeface="Calibri" pitchFamily="34" charset="-120"/>
               </a:rPr>
-              <a:t>Answers natural questions: 'Is it safe to walk my child to school tomorrow?'</a:t>
+              <a:t>Roadmap: answering natural questions like 'Is it safe to walk my child to school tomorrow?'</a:t>
             </a:r>
             <a:endParaRPr lang="en-US" sz="1250" dirty="0"/>
           </a:p>
@@ -5617,7 +5617,7 @@
                 <a:ea typeface="Calibri" pitchFamily="34" charset="-122"/>
                 <a:cs typeface="Calibri" pitchFamily="34" charset="-120"/>
               </a:rPr>
-              <a:t>Language coverage by city</a:t>
+              <a:t>Language coverage by city (Hindi live today; rest are roadmap)</a:t>
             </a:r>
             <a:endParaRPr lang="en-US" sz="1150" dirty="0"/>
           </a:p>
@@ -5711,7 +5711,7 @@
                 <a:ea typeface="Calibri" pitchFamily="34" charset="-122"/>
                 <a:cs typeface="Calibri" pitchFamily="34" charset="-120"/>
               </a:rPr>
-              <a:t>— Hindi</a:t>
+              <a:t>— Hindi (live)</a:t>
             </a:r>
             <a:endParaRPr lang="en-US" sz="1250" dirty="0"/>
           </a:p>
@@ -5805,7 +5805,7 @@
                 <a:ea typeface="Calibri" pitchFamily="34" charset="-122"/>
                 <a:cs typeface="Calibri" pitchFamily="34" charset="-120"/>
               </a:rPr>
-              <a:t>— Marathi</a:t>
+              <a:t>— Marathi (roadmap)</a:t>
             </a:r>
             <a:endParaRPr lang="en-US" sz="1250" dirty="0"/>
           </a:p>
@@ -5899,7 +5899,7 @@
                 <a:ea typeface="Calibri" pitchFamily="34" charset="-122"/>
                 <a:cs typeface="Calibri" pitchFamily="34" charset="-120"/>
               </a:rPr>
-              <a:t>— Bengali</a:t>
+              <a:t>— Bengali (roadmap)</a:t>
             </a:r>
             <a:endParaRPr lang="en-US" sz="1250" dirty="0"/>
           </a:p>
@@ -5993,7 +5993,7 @@
                 <a:ea typeface="Calibri" pitchFamily="34" charset="-122"/>
                 <a:cs typeface="Calibri" pitchFamily="34" charset="-120"/>
               </a:rPr>
-              <a:t>— Kannada</a:t>
+              <a:t>— Kannada (roadmap)</a:t>
             </a:r>
             <a:endParaRPr lang="en-US" sz="1250" dirty="0"/>
           </a:p>
@@ -6087,7 +6087,7 @@
                 <a:ea typeface="Calibri" pitchFamily="34" charset="-122"/>
                 <a:cs typeface="Calibri" pitchFamily="34" charset="-120"/>
               </a:rPr>
-              <a:t>— Tamil</a:t>
+              <a:t>— Tamil (roadmap)</a:t>
             </a:r>
             <a:endParaRPr lang="en-US" sz="1250" dirty="0"/>
           </a:p>
@@ -7999,7 +7999,7 @@
                 <a:ea typeface="Calibri" pitchFamily="34" charset="-122"/>
                 <a:cs typeface="Calibri" pitchFamily="34" charset="-120"/>
               </a:rPr>
-              <a:t>24h: 78.5 vs baseline 112.9 (30.5% better) • 48h: 78.5 vs 114.3 (31.3%) • 72h: 78.5 vs 114.2 (31.3%)</a:t>
+              <a:t>24h: 80.9 vs baseline 112.9 (28.3% better) • 48h: 82.6 vs 114.3 (27.8%) • 72h: 83.8 vs 114.2 (26.6%)</a:t>
             </a:r>
             <a:endParaRPr lang="en-US" sz="1050" dirty="0"/>
           </a:p>
@@ -8922,7 +8922,7 @@
                 <a:ea typeface="Calibri" pitchFamily="34" charset="-122"/>
                 <a:cs typeface="Calibri" pitchFamily="34" charset="-120"/>
               </a:rPr>
-              <a:t>Hybrid GBR + physics-based dispersion; causal inference; actual RMSE 78.5 vs 112.9 baseline (30.5% improvement).</a:t>
+              <a:t>Three per-horizon GBR models, wired live into the app, + wind-confounder attribution check, both running today; actual RMSE 80.9/82.6/83.8h vs 112.9/114.3/114.2 baseline (~27% improvement).</a:t>
             </a:r>
             <a:endParaRPr lang="en-US" sz="1050" dirty="0"/>
           </a:p>
@@ -9418,7 +9418,7 @@
                 <a:ea typeface="Calibri" pitchFamily="34" charset="-122"/>
                 <a:cs typeface="Calibri" pitchFamily="34" charset="-120"/>
               </a:rPr>
-              <a:t>Delhi NCR (live) + Mumbai (comparison)</a:t>
+              <a:t>All 5 cities live for basic comparison; Delhi NCR + Mumbai have deepest validation</a:t>
             </a:r>
             <a:endParaRPr lang="en-US" sz="1100" dirty="0"/>
           </a:p>
@@ -9593,7 +9593,7 @@
                 <a:ea typeface="Calibri" pitchFamily="34" charset="-122"/>
                 <a:cs typeface="Calibri" pitchFamily="34" charset="-120"/>
               </a:rPr>
-              <a:t>Kolkata, Bengaluru, Chennai onboarding</a:t>
+              <a:t>Extend forecast models + wind-check validation to Kolkata, Bengaluru, Chennai</a:t>
             </a:r>
             <a:endParaRPr lang="en-US" sz="1100" dirty="0"/>
           </a:p>
@@ -14943,7 +14943,7 @@
                 <a:ea typeface="Cambria" pitchFamily="34" charset="-122"/>
                 <a:cs typeface="Cambria" pitchFamily="34" charset="-120"/>
               </a:rPr>
-              <a:t>CPCB CAAQMS</a:t>
+              <a:t>OpenAQ v3 (CPCB-sourced)</a:t>
             </a:r>
             <a:endParaRPr lang="en-US" sz="1450" dirty="0"/>
           </a:p>
@@ -14982,7 +14982,7 @@
                 <a:ea typeface="Calibri" pitchFamily="34" charset="-122"/>
                 <a:cs typeface="Calibri" pitchFamily="34" charset="-120"/>
               </a:rPr>
-              <a:t>PM2.5, PM10, NO2, SO2, CO, O3 • 40+ stations • hourly</a:t>
+              <a:t>PM2.5, PM10, NO2, SO2, CO, O3 • all 5 cities • hourly • live today</a:t>
             </a:r>
             <a:endParaRPr lang="en-US" sz="1050" dirty="0"/>
           </a:p>
@@ -15284,7 +15284,7 @@
                 <a:ea typeface="Calibri" pitchFamily="34" charset="-122"/>
                 <a:cs typeface="Calibri" pitchFamily="34" charset="-120"/>
               </a:rPr>
-              <a:t>NO2 / SO2 / CO from orbit • daily, city-wide</a:t>
+              <a:t>NO2 / SO2 / CO from orbit • daily, city-wide • roadmap</a:t>
             </a:r>
             <a:endParaRPr lang="en-US" sz="1050" dirty="0"/>
           </a:p>
@@ -15435,7 +15435,7 @@
                 <a:ea typeface="Calibri" pitchFamily="34" charset="-122"/>
                 <a:cs typeface="Calibri" pitchFamily="34" charset="-120"/>
               </a:rPr>
-              <a:t>Crop-burning hotspots, Punjab &amp; Haryana</a:t>
+              <a:t>Crop-burning hotspots, Punjab &amp; Haryana • roadmap</a:t>
             </a:r>
             <a:endParaRPr lang="en-US" sz="1050" dirty="0"/>
           </a:p>
@@ -15586,7 +15586,7 @@
                 <a:ea typeface="Calibri" pitchFamily="34" charset="-122"/>
                 <a:cs typeface="Calibri" pitchFamily="34" charset="-120"/>
               </a:rPr>
-              <a:t>Industry, highways, construction, schools</a:t>
+              <a:t>Industry, highways, construction, schools • live today</a:t>
             </a:r>
             <a:endParaRPr lang="en-US" sz="1050" dirty="0"/>
           </a:p>
@@ -16664,7 +16664,7 @@
                 <a:ea typeface="Calibri" pitchFamily="34" charset="-122"/>
                 <a:cs typeface="Calibri" pitchFamily="34" charset="-120"/>
               </a:rPr>
-              <a:t>Graph Neural Network treats 40+ stations as a connected network — pollution moves with the wind from node to node.</a:t>
+              <a:t>Prototype (running today): three independently trained models, one per forecast horizon, on 5 years of Delhi data.</a:t>
             </a:r>
             <a:endParaRPr lang="en-US" sz="1250" dirty="0"/>
           </a:p>
@@ -16747,7 +16747,7 @@
                 <a:ea typeface="Calibri" pitchFamily="34" charset="-122"/>
                 <a:cs typeface="Calibri" pitchFamily="34" charset="-120"/>
               </a:rPr>
-              <a:t>Blended with a physics-based atmospheric dispersion model so predictions stay physically grounded, not just pattern-matched.</a:t>
+              <a:t>Roadmap: Graph Neural Network treating stations as a connected network, blended with a physics-based dispersion model.</a:t>
             </a:r>
             <a:endParaRPr lang="en-US" sz="1250" dirty="0"/>
           </a:p>

</xml_diff>